<commit_message>
chore: codex checkpoint (session-stop)
Automatic Codex checkpoint at 2026-08-31 15:48:30.

Reason: session-stop.
</commit_message>
<xml_diff>
--- a/presentations/2026-08-30_agenda_information_seminar/seminario_agenda_informacao.pptx
+++ b/presentations/2026-08-30_agenda_information_seminar/seminario_agenda_informacao.pptx
@@ -2,28 +2,28 @@
 <file path=ppt/presentation.xml><?xml version="1.0" encoding="utf-8"?>
 <p:presentation xmlns:p="http://schemas.openxmlformats.org/presentationml/2006/main">
   <p:sldMasterIdLst>
-    <p:sldMasterId xmlns:r="http://schemas.openxmlformats.org/officeDocument/2006/relationships" id="2147483648" r:id="Rb8a236563a0449fc"/>
+    <p:sldMasterId xmlns:r="http://schemas.openxmlformats.org/officeDocument/2006/relationships" id="2147483648" r:id="R43becbd963fa4672"/>
   </p:sldMasterIdLst>
   <p:notesMasterIdLst>
-    <p:notesMasterId xmlns:r="http://schemas.openxmlformats.org/officeDocument/2006/relationships" r:id="R18253497f92a4bc7"/>
+    <p:notesMasterId xmlns:r="http://schemas.openxmlformats.org/officeDocument/2006/relationships" r:id="R6166ef4cf1624a9f"/>
   </p:notesMasterIdLst>
   <p:sldIdLst>
-    <p:sldId xmlns:r="http://schemas.openxmlformats.org/officeDocument/2006/relationships" id="256" r:id="Re3a127f2c0fd4d07"/>
-    <p:sldId xmlns:r="http://schemas.openxmlformats.org/officeDocument/2006/relationships" id="257" r:id="R23d7c18414cb4efd"/>
-    <p:sldId xmlns:r="http://schemas.openxmlformats.org/officeDocument/2006/relationships" id="258" r:id="Ref5c00aa6a11461e"/>
-    <p:sldId xmlns:r="http://schemas.openxmlformats.org/officeDocument/2006/relationships" id="259" r:id="R4909a72314d6423b"/>
-    <p:sldId xmlns:r="http://schemas.openxmlformats.org/officeDocument/2006/relationships" id="260" r:id="R29e729b73d1b422e"/>
-    <p:sldId xmlns:r="http://schemas.openxmlformats.org/officeDocument/2006/relationships" id="261" r:id="R96e886238d6b4dc1"/>
-    <p:sldId xmlns:r="http://schemas.openxmlformats.org/officeDocument/2006/relationships" id="262" r:id="R6f5eb40464394c0b"/>
-    <p:sldId xmlns:r="http://schemas.openxmlformats.org/officeDocument/2006/relationships" id="263" r:id="Re94c039b159745ba"/>
-    <p:sldId xmlns:r="http://schemas.openxmlformats.org/officeDocument/2006/relationships" id="264" r:id="R085dd8f72222423b"/>
-    <p:sldId xmlns:r="http://schemas.openxmlformats.org/officeDocument/2006/relationships" id="265" r:id="R6b854cb77e374dcb"/>
-    <p:sldId xmlns:r="http://schemas.openxmlformats.org/officeDocument/2006/relationships" id="266" r:id="R26969e34020f4f9f"/>
-    <p:sldId xmlns:r="http://schemas.openxmlformats.org/officeDocument/2006/relationships" id="267" r:id="R537ed8af58e14cfe"/>
-    <p:sldId xmlns:r="http://schemas.openxmlformats.org/officeDocument/2006/relationships" id="268" r:id="Rac7dfd3e22a44f97"/>
-    <p:sldId xmlns:r="http://schemas.openxmlformats.org/officeDocument/2006/relationships" id="269" r:id="Rb5cc96463ec54b94"/>
-    <p:sldId xmlns:r="http://schemas.openxmlformats.org/officeDocument/2006/relationships" id="270" r:id="R83689d888d20426b"/>
-    <p:sldId xmlns:r="http://schemas.openxmlformats.org/officeDocument/2006/relationships" id="271" r:id="Re61edf4d75e84574"/>
+    <p:sldId xmlns:r="http://schemas.openxmlformats.org/officeDocument/2006/relationships" id="256" r:id="R6147eb68aa374411"/>
+    <p:sldId xmlns:r="http://schemas.openxmlformats.org/officeDocument/2006/relationships" id="257" r:id="Rc55f6529eea24be4"/>
+    <p:sldId xmlns:r="http://schemas.openxmlformats.org/officeDocument/2006/relationships" id="258" r:id="R035c389a766a4604"/>
+    <p:sldId xmlns:r="http://schemas.openxmlformats.org/officeDocument/2006/relationships" id="259" r:id="R8037326a1bf24eaf"/>
+    <p:sldId xmlns:r="http://schemas.openxmlformats.org/officeDocument/2006/relationships" id="260" r:id="R042c2a22ae004161"/>
+    <p:sldId xmlns:r="http://schemas.openxmlformats.org/officeDocument/2006/relationships" id="261" r:id="Rdfe21713aa234b46"/>
+    <p:sldId xmlns:r="http://schemas.openxmlformats.org/officeDocument/2006/relationships" id="262" r:id="Rb55f4a8760594fec"/>
+    <p:sldId xmlns:r="http://schemas.openxmlformats.org/officeDocument/2006/relationships" id="263" r:id="R504b0d1023eb4355"/>
+    <p:sldId xmlns:r="http://schemas.openxmlformats.org/officeDocument/2006/relationships" id="264" r:id="Reb1ecd060e3f442f"/>
+    <p:sldId xmlns:r="http://schemas.openxmlformats.org/officeDocument/2006/relationships" id="265" r:id="R453452dc6a164f21"/>
+    <p:sldId xmlns:r="http://schemas.openxmlformats.org/officeDocument/2006/relationships" id="266" r:id="R729750d16a814209"/>
+    <p:sldId xmlns:r="http://schemas.openxmlformats.org/officeDocument/2006/relationships" id="267" r:id="Rf97f581002f644e9"/>
+    <p:sldId xmlns:r="http://schemas.openxmlformats.org/officeDocument/2006/relationships" id="268" r:id="R4fd6170e833b43ec"/>
+    <p:sldId xmlns:r="http://schemas.openxmlformats.org/officeDocument/2006/relationships" id="269" r:id="R8e3a3e5b34124a78"/>
+    <p:sldId xmlns:r="http://schemas.openxmlformats.org/officeDocument/2006/relationships" id="270" r:id="R2a6e67eda3064aa4"/>
+    <p:sldId xmlns:r="http://schemas.openxmlformats.org/officeDocument/2006/relationships" id="271" r:id="R495b55676eca47ff"/>
   </p:sldIdLst>
   <p:sldSz cx="12192000" cy="6858000"/>
   <p:notesSz cx="6858000" cy="9144000"/>
@@ -1511,7 +1511,7 @@
   </p:cSld>
   <p:clrMap bg1="lt1" tx1="dk1" bg2="lt2" tx2="dk2" accent1="accent1" accent2="accent2" accent3="accent3" accent4="accent4" accent5="accent5" accent6="accent6" hlink="hlink" folHlink="folHlink"/>
   <p:sldLayoutIdLst>
-    <p:sldLayoutId xmlns:r="http://schemas.openxmlformats.org/officeDocument/2006/relationships" id="2147483649" r:id="Rd161b803b9684691"/>
+    <p:sldLayoutId xmlns:r="http://schemas.openxmlformats.org/officeDocument/2006/relationships" id="2147483649" r:id="R81dd909a1d644386"/>
   </p:sldLayoutIdLst>
   <p:txStyles>
     <p:titleStyle>
@@ -2062,7 +2062,7 @@
           <p:cNvPr id="9" name="">
             <a:extLst xmlns:a="http://schemas.openxmlformats.org/drawingml/2006/main">
               <a:ext uri="{FF2B5EF4-FFF2-40B4-BE49-F238E27FC236}">
-                <a16:creationId xmlns:a16="http://schemas.microsoft.com/office/drawing/2014/main" id="{4A6FFA8D-A3E3-4BD2-818A-33B2DD8CE7D1}"/>
+                <a16:creationId xmlns:a16="http://schemas.microsoft.com/office/drawing/2014/main" id="{51417A9F-FA1D-4BAC-B548-D7B196E9B8B5}"/>
               </a:ext>
             </a:extLst>
           </p:cNvPr>
@@ -2093,7 +2093,7 @@
           <p:cNvPr id="2" name="">
             <a:extLst xmlns:a="http://schemas.openxmlformats.org/drawingml/2006/main">
               <a:ext uri="{FF2B5EF4-FFF2-40B4-BE49-F238E27FC236}">
-                <a16:creationId xmlns:a16="http://schemas.microsoft.com/office/drawing/2014/main" id="{5BD77698-1F4D-419D-B1B7-FFB30BF1CEF5}"/>
+                <a16:creationId xmlns:a16="http://schemas.microsoft.com/office/drawing/2014/main" id="{02471644-9169-4CFC-8772-A44C4C6A3C0B}"/>
               </a:ext>
             </a:extLst>
           </p:cNvPr>
@@ -2162,7 +2162,7 @@
           <p:cNvPr id="3" name="">
             <a:extLst xmlns:a="http://schemas.openxmlformats.org/drawingml/2006/main">
               <a:ext uri="{FF2B5EF4-FFF2-40B4-BE49-F238E27FC236}">
-                <a16:creationId xmlns:a16="http://schemas.microsoft.com/office/drawing/2014/main" id="{F86426D4-92C0-4F83-A4B2-BE220D839751}"/>
+                <a16:creationId xmlns:a16="http://schemas.microsoft.com/office/drawing/2014/main" id="{36BB2BF8-BD89-4159-A924-D07589584A55}"/>
               </a:ext>
             </a:extLst>
           </p:cNvPr>
@@ -2214,7 +2214,7 @@
           <p:cNvPr id="4" name="">
             <a:extLst xmlns:a="http://schemas.openxmlformats.org/drawingml/2006/main">
               <a:ext uri="{FF2B5EF4-FFF2-40B4-BE49-F238E27FC236}">
-                <a16:creationId xmlns:a16="http://schemas.microsoft.com/office/drawing/2014/main" id="{19588ACB-9F49-4AB8-AFF6-0A4880CB3494}"/>
+                <a16:creationId xmlns:a16="http://schemas.microsoft.com/office/drawing/2014/main" id="{3D010A76-7F03-4FD7-B8E6-B9AB6D4CF528}"/>
               </a:ext>
             </a:extLst>
           </p:cNvPr>
@@ -2255,7 +2255,7 @@
           <p:cNvPr id="5" name="">
             <a:extLst xmlns:a="http://schemas.openxmlformats.org/drawingml/2006/main">
               <a:ext uri="{FF2B5EF4-FFF2-40B4-BE49-F238E27FC236}">
-                <a16:creationId xmlns:a16="http://schemas.microsoft.com/office/drawing/2014/main" id="{78526506-0B4F-4875-8EE5-C1E8EB11A38B}"/>
+                <a16:creationId xmlns:a16="http://schemas.microsoft.com/office/drawing/2014/main" id="{F7F6F427-D8D6-4986-B3B0-7DE713ABFC92}"/>
               </a:ext>
             </a:extLst>
           </p:cNvPr>
@@ -2286,7 +2286,7 @@
           <p:cNvPr id="6" name="">
             <a:extLst xmlns:a="http://schemas.openxmlformats.org/drawingml/2006/main">
               <a:ext uri="{FF2B5EF4-FFF2-40B4-BE49-F238E27FC236}">
-                <a16:creationId xmlns:a16="http://schemas.microsoft.com/office/drawing/2014/main" id="{1EEBC9A7-7C49-4AB4-90A4-7FB76EC08DAB}"/>
+                <a16:creationId xmlns:a16="http://schemas.microsoft.com/office/drawing/2014/main" id="{125FB518-65EB-4BE7-B252-4D6D44E526DF}"/>
               </a:ext>
             </a:extLst>
           </p:cNvPr>
@@ -2338,7 +2338,7 @@
           <p:cNvPr id="7" name="">
             <a:extLst xmlns:a="http://schemas.openxmlformats.org/drawingml/2006/main">
               <a:ext uri="{FF2B5EF4-FFF2-40B4-BE49-F238E27FC236}">
-                <a16:creationId xmlns:a16="http://schemas.microsoft.com/office/drawing/2014/main" id="{0F4398B8-96D3-404E-B855-BB48617D3764}"/>
+                <a16:creationId xmlns:a16="http://schemas.microsoft.com/office/drawing/2014/main" id="{BB3973C1-94BB-487C-9715-3D7908001AD2}"/>
               </a:ext>
             </a:extLst>
           </p:cNvPr>
@@ -2390,7 +2390,7 @@
           <p:cNvPr id="8" name="">
             <a:extLst xmlns:a="http://schemas.openxmlformats.org/drawingml/2006/main">
               <a:ext uri="{FF2B5EF4-FFF2-40B4-BE49-F238E27FC236}">
-                <a16:creationId xmlns:a16="http://schemas.microsoft.com/office/drawing/2014/main" id="{499F5D01-4F3D-4CE7-BA8A-14ADE6502824}"/>
+                <a16:creationId xmlns:a16="http://schemas.microsoft.com/office/drawing/2014/main" id="{917799CF-9FC3-4DEE-90FA-318A43C59AD3}"/>
               </a:ext>
             </a:extLst>
           </p:cNvPr>
@@ -2440,7 +2440,7 @@
     </p:spTree>
     <p:extLst>
       <p:ext uri="{BB962C8B-B14F-4D97-AF65-F5344CB8AC3E}">
-        <p14:creationId xmlns:p14="http://schemas.microsoft.com/office/powerpoint/2010/main" val="679406427"/>
+        <p14:creationId xmlns:p14="http://schemas.microsoft.com/office/powerpoint/2010/main" val="1163727810"/>
       </p:ext>
     </p:extLst>
   </p:cSld>
@@ -2475,7 +2475,7 @@
           <p:nvPr/>
         </p:nvPicPr>
         <p:blipFill>
-          <a:blip xmlns:r="http://schemas.openxmlformats.org/officeDocument/2006/relationships" xmlns:a="http://schemas.openxmlformats.org/drawingml/2006/main" r:embed="R1c43fdd140a144ce"/>
+          <a:blip xmlns:r="http://schemas.openxmlformats.org/officeDocument/2006/relationships" xmlns:a="http://schemas.openxmlformats.org/drawingml/2006/main" r:embed="Re3434c0dda694005"/>
           <a:stretch xmlns:a="http://schemas.openxmlformats.org/drawingml/2006/main"/>
         </p:blipFill>
         <p:spPr>
@@ -2491,7 +2491,7 @@
     </p:spTree>
     <p:extLst>
       <p:ext uri="{BB962C8B-B14F-4D97-AF65-F5344CB8AC3E}">
-        <p14:creationId xmlns:p14="http://schemas.microsoft.com/office/powerpoint/2010/main" val="2021165475"/>
+        <p14:creationId xmlns:p14="http://schemas.microsoft.com/office/powerpoint/2010/main" val="643312194"/>
       </p:ext>
     </p:extLst>
   </p:cSld>
@@ -2522,7 +2522,7 @@
           <p:cNvPr id="14" name="">
             <a:extLst xmlns:a="http://schemas.openxmlformats.org/drawingml/2006/main">
               <a:ext uri="{FF2B5EF4-FFF2-40B4-BE49-F238E27FC236}">
-                <a16:creationId xmlns:a16="http://schemas.microsoft.com/office/drawing/2014/main" id="{8D89BF11-1A56-40D1-8A6A-9EE982954DBC}"/>
+                <a16:creationId xmlns:a16="http://schemas.microsoft.com/office/drawing/2014/main" id="{DC7BEFDE-4A11-465B-B090-0A8412F9414F}"/>
               </a:ext>
             </a:extLst>
           </p:cNvPr>
@@ -2574,7 +2574,7 @@
           <p:cNvPr id="2" name="">
             <a:extLst xmlns:a="http://schemas.openxmlformats.org/drawingml/2006/main">
               <a:ext uri="{FF2B5EF4-FFF2-40B4-BE49-F238E27FC236}">
-                <a16:creationId xmlns:a16="http://schemas.microsoft.com/office/drawing/2014/main" id="{0C16E944-CF57-49A8-A118-A877B7A70514}"/>
+                <a16:creationId xmlns:a16="http://schemas.microsoft.com/office/drawing/2014/main" id="{941F3477-64A6-4C99-B209-999740A8E597}"/>
               </a:ext>
             </a:extLst>
           </p:cNvPr>
@@ -2605,7 +2605,7 @@
           <p:cNvPr id="3" name="">
             <a:extLst xmlns:a="http://schemas.openxmlformats.org/drawingml/2006/main">
               <a:ext uri="{FF2B5EF4-FFF2-40B4-BE49-F238E27FC236}">
-                <a16:creationId xmlns:a16="http://schemas.microsoft.com/office/drawing/2014/main" id="{23B01534-7757-49E7-A18A-F1711CA05490}"/>
+                <a16:creationId xmlns:a16="http://schemas.microsoft.com/office/drawing/2014/main" id="{7382D949-2FE2-488F-BD74-076FFA06A0F0}"/>
               </a:ext>
             </a:extLst>
           </p:cNvPr>
@@ -2657,7 +2657,7 @@
           <p:cNvPr id="4" name="">
             <a:extLst xmlns:a="http://schemas.openxmlformats.org/drawingml/2006/main">
               <a:ext uri="{FF2B5EF4-FFF2-40B4-BE49-F238E27FC236}">
-                <a16:creationId xmlns:a16="http://schemas.microsoft.com/office/drawing/2014/main" id="{27D8EFC3-9907-45E8-9B91-F9D044CA4045}"/>
+                <a16:creationId xmlns:a16="http://schemas.microsoft.com/office/drawing/2014/main" id="{A4CA0C36-972A-48DF-B96F-B9ED5037BD65}"/>
               </a:ext>
             </a:extLst>
           </p:cNvPr>
@@ -2698,7 +2698,7 @@
           <p:cNvPr id="5" name="">
             <a:extLst xmlns:a="http://schemas.openxmlformats.org/drawingml/2006/main">
               <a:ext uri="{FF2B5EF4-FFF2-40B4-BE49-F238E27FC236}">
-                <a16:creationId xmlns:a16="http://schemas.microsoft.com/office/drawing/2014/main" id="{B07E2D1D-B558-4CF2-B635-2B487DF89785}"/>
+                <a16:creationId xmlns:a16="http://schemas.microsoft.com/office/drawing/2014/main" id="{860CE29B-2F41-4716-9368-1862BDF5AF92}"/>
               </a:ext>
             </a:extLst>
           </p:cNvPr>
@@ -2729,7 +2729,7 @@
           <p:cNvPr id="6" name="">
             <a:extLst xmlns:a="http://schemas.openxmlformats.org/drawingml/2006/main">
               <a:ext uri="{FF2B5EF4-FFF2-40B4-BE49-F238E27FC236}">
-                <a16:creationId xmlns:a16="http://schemas.microsoft.com/office/drawing/2014/main" id="{E3100647-6252-415F-B881-8FEE55635305}"/>
+                <a16:creationId xmlns:a16="http://schemas.microsoft.com/office/drawing/2014/main" id="{06AFF718-CE24-44F6-B3AA-E65FF1798422}"/>
               </a:ext>
             </a:extLst>
           </p:cNvPr>
@@ -2781,7 +2781,7 @@
           <p:cNvPr id="7" name="">
             <a:extLst xmlns:a="http://schemas.openxmlformats.org/drawingml/2006/main">
               <a:ext uri="{FF2B5EF4-FFF2-40B4-BE49-F238E27FC236}">
-                <a16:creationId xmlns:a16="http://schemas.microsoft.com/office/drawing/2014/main" id="{0C0B74B2-6B54-405D-8F1C-DB20948599C3}"/>
+                <a16:creationId xmlns:a16="http://schemas.microsoft.com/office/drawing/2014/main" id="{879801C7-543C-4359-9C78-F45C1812DFEE}"/>
               </a:ext>
             </a:extLst>
           </p:cNvPr>
@@ -2884,7 +2884,7 @@
           <p:cNvPr id="8" name="">
             <a:extLst xmlns:a="http://schemas.openxmlformats.org/drawingml/2006/main">
               <a:ext uri="{FF2B5EF4-FFF2-40B4-BE49-F238E27FC236}">
-                <a16:creationId xmlns:a16="http://schemas.microsoft.com/office/drawing/2014/main" id="{6155E540-4769-418F-AAE6-912B308F2E88}"/>
+                <a16:creationId xmlns:a16="http://schemas.microsoft.com/office/drawing/2014/main" id="{4F910AF8-A7CC-4CDD-8E86-55D9B2EEC004}"/>
               </a:ext>
             </a:extLst>
           </p:cNvPr>
@@ -2925,7 +2925,7 @@
           <p:cNvPr id="9" name="">
             <a:extLst xmlns:a="http://schemas.openxmlformats.org/drawingml/2006/main">
               <a:ext uri="{FF2B5EF4-FFF2-40B4-BE49-F238E27FC236}">
-                <a16:creationId xmlns:a16="http://schemas.microsoft.com/office/drawing/2014/main" id="{21D60661-989F-46F4-8871-15DC007BFD7C}"/>
+                <a16:creationId xmlns:a16="http://schemas.microsoft.com/office/drawing/2014/main" id="{83E6DCA4-AEA6-4A4E-BED6-7E0B2EACD63D}"/>
               </a:ext>
             </a:extLst>
           </p:cNvPr>
@@ -2956,7 +2956,7 @@
           <p:cNvPr id="10" name="">
             <a:extLst xmlns:a="http://schemas.openxmlformats.org/drawingml/2006/main">
               <a:ext uri="{FF2B5EF4-FFF2-40B4-BE49-F238E27FC236}">
-                <a16:creationId xmlns:a16="http://schemas.microsoft.com/office/drawing/2014/main" id="{86CDA026-793B-4739-AE62-A35083AA4D85}"/>
+                <a16:creationId xmlns:a16="http://schemas.microsoft.com/office/drawing/2014/main" id="{561C6C0C-061B-43D4-99A3-BE253FFDE736}"/>
               </a:ext>
             </a:extLst>
           </p:cNvPr>
@@ -3008,7 +3008,7 @@
           <p:cNvPr id="11" name="">
             <a:extLst xmlns:a="http://schemas.openxmlformats.org/drawingml/2006/main">
               <a:ext uri="{FF2B5EF4-FFF2-40B4-BE49-F238E27FC236}">
-                <a16:creationId xmlns:a16="http://schemas.microsoft.com/office/drawing/2014/main" id="{94645BCF-204D-4607-B7BA-0C0FC358DC12}"/>
+                <a16:creationId xmlns:a16="http://schemas.microsoft.com/office/drawing/2014/main" id="{C75EE437-B0E4-48E6-94D4-6A07DB586D66}"/>
               </a:ext>
             </a:extLst>
           </p:cNvPr>
@@ -3111,7 +3111,7 @@
           <p:cNvPr id="12" name="">
             <a:extLst xmlns:a="http://schemas.openxmlformats.org/drawingml/2006/main">
               <a:ext uri="{FF2B5EF4-FFF2-40B4-BE49-F238E27FC236}">
-                <a16:creationId xmlns:a16="http://schemas.microsoft.com/office/drawing/2014/main" id="{5B82605E-C172-418E-8A9F-D3E8A0762605}"/>
+                <a16:creationId xmlns:a16="http://schemas.microsoft.com/office/drawing/2014/main" id="{959692AE-1F79-4609-AA24-613A34E94E7B}"/>
               </a:ext>
             </a:extLst>
           </p:cNvPr>
@@ -3163,7 +3163,7 @@
           <p:cNvPr id="13" name="">
             <a:extLst xmlns:a="http://schemas.openxmlformats.org/drawingml/2006/main">
               <a:ext uri="{FF2B5EF4-FFF2-40B4-BE49-F238E27FC236}">
-                <a16:creationId xmlns:a16="http://schemas.microsoft.com/office/drawing/2014/main" id="{555DD7BF-CAF0-49BB-A523-C557C792E3B8}"/>
+                <a16:creationId xmlns:a16="http://schemas.microsoft.com/office/drawing/2014/main" id="{29F24964-518D-4A6C-94D9-2948BC053697}"/>
               </a:ext>
             </a:extLst>
           </p:cNvPr>
@@ -3213,7 +3213,7 @@
     </p:spTree>
     <p:extLst>
       <p:ext uri="{BB962C8B-B14F-4D97-AF65-F5344CB8AC3E}">
-        <p14:creationId xmlns:p14="http://schemas.microsoft.com/office/powerpoint/2010/main" val="297479765"/>
+        <p14:creationId xmlns:p14="http://schemas.microsoft.com/office/powerpoint/2010/main" val="1997238777"/>
       </p:ext>
     </p:extLst>
   </p:cSld>
@@ -3244,7 +3244,7 @@
           <p:cNvPr id="14" name="">
             <a:extLst xmlns:a="http://schemas.openxmlformats.org/drawingml/2006/main">
               <a:ext uri="{FF2B5EF4-FFF2-40B4-BE49-F238E27FC236}">
-                <a16:creationId xmlns:a16="http://schemas.microsoft.com/office/drawing/2014/main" id="{46EA04EB-F574-41DE-BEC4-413D1B3BC565}"/>
+                <a16:creationId xmlns:a16="http://schemas.microsoft.com/office/drawing/2014/main" id="{B4837AEF-6B51-4A7E-86F3-845775A42BA1}"/>
               </a:ext>
             </a:extLst>
           </p:cNvPr>
@@ -3296,7 +3296,7 @@
           <p:cNvPr id="2" name="">
             <a:extLst xmlns:a="http://schemas.openxmlformats.org/drawingml/2006/main">
               <a:ext uri="{FF2B5EF4-FFF2-40B4-BE49-F238E27FC236}">
-                <a16:creationId xmlns:a16="http://schemas.microsoft.com/office/drawing/2014/main" id="{1D9CD3C2-48F9-4A3E-8072-BF620328662A}"/>
+                <a16:creationId xmlns:a16="http://schemas.microsoft.com/office/drawing/2014/main" id="{500CC49F-7876-4E9E-95E5-8A94D68169CD}"/>
               </a:ext>
             </a:extLst>
           </p:cNvPr>
@@ -3327,7 +3327,7 @@
           <p:cNvPr id="3" name="">
             <a:extLst xmlns:a="http://schemas.openxmlformats.org/drawingml/2006/main">
               <a:ext uri="{FF2B5EF4-FFF2-40B4-BE49-F238E27FC236}">
-                <a16:creationId xmlns:a16="http://schemas.microsoft.com/office/drawing/2014/main" id="{274CFC35-C306-46E4-B348-30E688F3C347}"/>
+                <a16:creationId xmlns:a16="http://schemas.microsoft.com/office/drawing/2014/main" id="{653D11BE-ED1D-4014-9858-56439C1F8DF5}"/>
               </a:ext>
             </a:extLst>
           </p:cNvPr>
@@ -3379,7 +3379,7 @@
           <p:cNvPr id="4" name="">
             <a:extLst xmlns:a="http://schemas.openxmlformats.org/drawingml/2006/main">
               <a:ext uri="{FF2B5EF4-FFF2-40B4-BE49-F238E27FC236}">
-                <a16:creationId xmlns:a16="http://schemas.microsoft.com/office/drawing/2014/main" id="{2E25313A-DD30-4E02-B1F3-EB1DF89DD834}"/>
+                <a16:creationId xmlns:a16="http://schemas.microsoft.com/office/drawing/2014/main" id="{82516F46-14DF-4788-B0B9-A5D91BB0667F}"/>
               </a:ext>
             </a:extLst>
           </p:cNvPr>
@@ -3420,7 +3420,7 @@
           <p:cNvPr id="5" name="">
             <a:extLst xmlns:a="http://schemas.openxmlformats.org/drawingml/2006/main">
               <a:ext uri="{FF2B5EF4-FFF2-40B4-BE49-F238E27FC236}">
-                <a16:creationId xmlns:a16="http://schemas.microsoft.com/office/drawing/2014/main" id="{5CD53629-6B30-408C-ADC5-FBE2D7458D95}"/>
+                <a16:creationId xmlns:a16="http://schemas.microsoft.com/office/drawing/2014/main" id="{D34707A5-B7BB-46EE-AA11-E2DCBD7255F9}"/>
               </a:ext>
             </a:extLst>
           </p:cNvPr>
@@ -3451,7 +3451,7 @@
           <p:cNvPr id="6" name="">
             <a:extLst xmlns:a="http://schemas.openxmlformats.org/drawingml/2006/main">
               <a:ext uri="{FF2B5EF4-FFF2-40B4-BE49-F238E27FC236}">
-                <a16:creationId xmlns:a16="http://schemas.microsoft.com/office/drawing/2014/main" id="{51BBB38B-9BCE-493C-9ED2-728828C1EE87}"/>
+                <a16:creationId xmlns:a16="http://schemas.microsoft.com/office/drawing/2014/main" id="{3C506CBD-AFE8-4147-9FDD-FBBFD8CFBDF3}"/>
               </a:ext>
             </a:extLst>
           </p:cNvPr>
@@ -3503,7 +3503,7 @@
           <p:cNvPr id="7" name="">
             <a:extLst xmlns:a="http://schemas.openxmlformats.org/drawingml/2006/main">
               <a:ext uri="{FF2B5EF4-FFF2-40B4-BE49-F238E27FC236}">
-                <a16:creationId xmlns:a16="http://schemas.microsoft.com/office/drawing/2014/main" id="{09E97B3A-B616-4D09-BBFB-F9FBC5FEB43E}"/>
+                <a16:creationId xmlns:a16="http://schemas.microsoft.com/office/drawing/2014/main" id="{B41D8106-2FD5-4311-AF5B-C7A52F97E917}"/>
               </a:ext>
             </a:extLst>
           </p:cNvPr>
@@ -3606,7 +3606,7 @@
           <p:cNvPr id="8" name="">
             <a:extLst xmlns:a="http://schemas.openxmlformats.org/drawingml/2006/main">
               <a:ext uri="{FF2B5EF4-FFF2-40B4-BE49-F238E27FC236}">
-                <a16:creationId xmlns:a16="http://schemas.microsoft.com/office/drawing/2014/main" id="{B6D16621-BF43-4064-A32D-BA26D21489A3}"/>
+                <a16:creationId xmlns:a16="http://schemas.microsoft.com/office/drawing/2014/main" id="{030F0109-EB33-436D-9F67-639F55953437}"/>
               </a:ext>
             </a:extLst>
           </p:cNvPr>
@@ -3647,7 +3647,7 @@
           <p:cNvPr id="9" name="">
             <a:extLst xmlns:a="http://schemas.openxmlformats.org/drawingml/2006/main">
               <a:ext uri="{FF2B5EF4-FFF2-40B4-BE49-F238E27FC236}">
-                <a16:creationId xmlns:a16="http://schemas.microsoft.com/office/drawing/2014/main" id="{AD98B118-7326-4DB3-85E5-FF6F3F1A5559}"/>
+                <a16:creationId xmlns:a16="http://schemas.microsoft.com/office/drawing/2014/main" id="{2BD8A93D-356B-4660-8ED5-D5E1F9F136E4}"/>
               </a:ext>
             </a:extLst>
           </p:cNvPr>
@@ -3678,7 +3678,7 @@
           <p:cNvPr id="10" name="">
             <a:extLst xmlns:a="http://schemas.openxmlformats.org/drawingml/2006/main">
               <a:ext uri="{FF2B5EF4-FFF2-40B4-BE49-F238E27FC236}">
-                <a16:creationId xmlns:a16="http://schemas.microsoft.com/office/drawing/2014/main" id="{95092980-5435-40FD-BBFC-62D8D153E820}"/>
+                <a16:creationId xmlns:a16="http://schemas.microsoft.com/office/drawing/2014/main" id="{FB92DBE4-054C-46BB-9385-191025FCE9B4}"/>
               </a:ext>
             </a:extLst>
           </p:cNvPr>
@@ -3730,7 +3730,7 @@
           <p:cNvPr id="11" name="">
             <a:extLst xmlns:a="http://schemas.openxmlformats.org/drawingml/2006/main">
               <a:ext uri="{FF2B5EF4-FFF2-40B4-BE49-F238E27FC236}">
-                <a16:creationId xmlns:a16="http://schemas.microsoft.com/office/drawing/2014/main" id="{31367073-8194-4D34-8883-9CC424DB3E10}"/>
+                <a16:creationId xmlns:a16="http://schemas.microsoft.com/office/drawing/2014/main" id="{639D2625-9AFD-445D-9B51-73F5F7411AB5}"/>
               </a:ext>
             </a:extLst>
           </p:cNvPr>
@@ -3833,7 +3833,7 @@
           <p:cNvPr id="12" name="">
             <a:extLst xmlns:a="http://schemas.openxmlformats.org/drawingml/2006/main">
               <a:ext uri="{FF2B5EF4-FFF2-40B4-BE49-F238E27FC236}">
-                <a16:creationId xmlns:a16="http://schemas.microsoft.com/office/drawing/2014/main" id="{0D9C9E78-B63D-4894-AADE-D7B0397478F3}"/>
+                <a16:creationId xmlns:a16="http://schemas.microsoft.com/office/drawing/2014/main" id="{22CAE6F4-428D-40EF-9CFB-AB33D8A121D4}"/>
               </a:ext>
             </a:extLst>
           </p:cNvPr>
@@ -3885,7 +3885,7 @@
           <p:cNvPr id="13" name="">
             <a:extLst xmlns:a="http://schemas.openxmlformats.org/drawingml/2006/main">
               <a:ext uri="{FF2B5EF4-FFF2-40B4-BE49-F238E27FC236}">
-                <a16:creationId xmlns:a16="http://schemas.microsoft.com/office/drawing/2014/main" id="{23F3C81B-4059-4B6D-8478-BABE58F9C843}"/>
+                <a16:creationId xmlns:a16="http://schemas.microsoft.com/office/drawing/2014/main" id="{F9D3A282-739D-4374-915C-2E8E2437C319}"/>
               </a:ext>
             </a:extLst>
           </p:cNvPr>
@@ -3935,7 +3935,7 @@
     </p:spTree>
     <p:extLst>
       <p:ext uri="{BB962C8B-B14F-4D97-AF65-F5344CB8AC3E}">
-        <p14:creationId xmlns:p14="http://schemas.microsoft.com/office/powerpoint/2010/main" val="1798302725"/>
+        <p14:creationId xmlns:p14="http://schemas.microsoft.com/office/powerpoint/2010/main" val="1933308227"/>
       </p:ext>
     </p:extLst>
   </p:cSld>
@@ -3966,7 +3966,7 @@
           <p:cNvPr id="28" name="">
             <a:extLst xmlns:a="http://schemas.openxmlformats.org/drawingml/2006/main">
               <a:ext uri="{FF2B5EF4-FFF2-40B4-BE49-F238E27FC236}">
-                <a16:creationId xmlns:a16="http://schemas.microsoft.com/office/drawing/2014/main" id="{7425666C-9345-42F5-B79F-9AFC80AB10BF}"/>
+                <a16:creationId xmlns:a16="http://schemas.microsoft.com/office/drawing/2014/main" id="{4B00738B-DBF0-4AEE-B31F-CD8ED3D6816A}"/>
               </a:ext>
             </a:extLst>
           </p:cNvPr>
@@ -4018,7 +4018,7 @@
           <p:cNvPr id="2" name="">
             <a:extLst xmlns:a="http://schemas.openxmlformats.org/drawingml/2006/main">
               <a:ext uri="{FF2B5EF4-FFF2-40B4-BE49-F238E27FC236}">
-                <a16:creationId xmlns:a16="http://schemas.microsoft.com/office/drawing/2014/main" id="{BB568F17-22A4-4660-8D5E-E6D737CBD651}"/>
+                <a16:creationId xmlns:a16="http://schemas.microsoft.com/office/drawing/2014/main" id="{9519EBA3-F01C-4F0D-8E54-E8FE4CEE7E05}"/>
               </a:ext>
             </a:extLst>
           </p:cNvPr>
@@ -4049,7 +4049,7 @@
           <p:cNvPr id="3" name="">
             <a:extLst xmlns:a="http://schemas.openxmlformats.org/drawingml/2006/main">
               <a:ext uri="{FF2B5EF4-FFF2-40B4-BE49-F238E27FC236}">
-                <a16:creationId xmlns:a16="http://schemas.microsoft.com/office/drawing/2014/main" id="{4348BFED-BDFD-4338-B017-64BFF40D0AC0}"/>
+                <a16:creationId xmlns:a16="http://schemas.microsoft.com/office/drawing/2014/main" id="{6336FF56-3CC5-4136-90DD-6E743A12273C}"/>
               </a:ext>
             </a:extLst>
           </p:cNvPr>
@@ -4101,7 +4101,7 @@
           <p:cNvPr id="4" name="">
             <a:extLst xmlns:a="http://schemas.openxmlformats.org/drawingml/2006/main">
               <a:ext uri="{FF2B5EF4-FFF2-40B4-BE49-F238E27FC236}">
-                <a16:creationId xmlns:a16="http://schemas.microsoft.com/office/drawing/2014/main" id="{CB731F05-C86C-4EAE-8811-923D272643C0}"/>
+                <a16:creationId xmlns:a16="http://schemas.microsoft.com/office/drawing/2014/main" id="{D89FAA30-7F49-4401-A0C2-992C60123DF3}"/>
               </a:ext>
             </a:extLst>
           </p:cNvPr>
@@ -4142,7 +4142,7 @@
           <p:cNvPr id="5" name="">
             <a:extLst xmlns:a="http://schemas.openxmlformats.org/drawingml/2006/main">
               <a:ext uri="{FF2B5EF4-FFF2-40B4-BE49-F238E27FC236}">
-                <a16:creationId xmlns:a16="http://schemas.microsoft.com/office/drawing/2014/main" id="{86731206-AADC-441A-B2A5-ADD615FE53C2}"/>
+                <a16:creationId xmlns:a16="http://schemas.microsoft.com/office/drawing/2014/main" id="{4E71274B-9815-4D03-8149-B202095AC7B1}"/>
               </a:ext>
             </a:extLst>
           </p:cNvPr>
@@ -4173,7 +4173,7 @@
           <p:cNvPr id="6" name="">
             <a:extLst xmlns:a="http://schemas.openxmlformats.org/drawingml/2006/main">
               <a:ext uri="{FF2B5EF4-FFF2-40B4-BE49-F238E27FC236}">
-                <a16:creationId xmlns:a16="http://schemas.microsoft.com/office/drawing/2014/main" id="{8A0DAAFD-8892-4558-8CE9-D968A8BD8439}"/>
+                <a16:creationId xmlns:a16="http://schemas.microsoft.com/office/drawing/2014/main" id="{645E7B3B-D36E-4171-B4C2-0CF3222BF8E7}"/>
               </a:ext>
             </a:extLst>
           </p:cNvPr>
@@ -4225,7 +4225,7 @@
           <p:cNvPr id="7" name="">
             <a:extLst xmlns:a="http://schemas.openxmlformats.org/drawingml/2006/main">
               <a:ext uri="{FF2B5EF4-FFF2-40B4-BE49-F238E27FC236}">
-                <a16:creationId xmlns:a16="http://schemas.microsoft.com/office/drawing/2014/main" id="{B24DC4F2-200E-4DFD-9792-34C9A981E713}"/>
+                <a16:creationId xmlns:a16="http://schemas.microsoft.com/office/drawing/2014/main" id="{CE55A848-F839-428A-99DF-D12543A1FC50}"/>
               </a:ext>
             </a:extLst>
           </p:cNvPr>
@@ -4294,7 +4294,7 @@
           <p:cNvPr id="8" name="">
             <a:extLst xmlns:a="http://schemas.openxmlformats.org/drawingml/2006/main">
               <a:ext uri="{FF2B5EF4-FFF2-40B4-BE49-F238E27FC236}">
-                <a16:creationId xmlns:a16="http://schemas.microsoft.com/office/drawing/2014/main" id="{7D27CB72-5766-4A30-99EC-E4954D4A05BC}"/>
+                <a16:creationId xmlns:a16="http://schemas.microsoft.com/office/drawing/2014/main" id="{9D2BFBC4-1CB2-43E9-B11B-F86C191ED4AF}"/>
               </a:ext>
             </a:extLst>
           </p:cNvPr>
@@ -4346,7 +4346,7 @@
           <p:cNvPr id="9" name="">
             <a:extLst xmlns:a="http://schemas.openxmlformats.org/drawingml/2006/main">
               <a:ext uri="{FF2B5EF4-FFF2-40B4-BE49-F238E27FC236}">
-                <a16:creationId xmlns:a16="http://schemas.microsoft.com/office/drawing/2014/main" id="{E4A4DD6E-C476-4378-8594-E13435202493}"/>
+                <a16:creationId xmlns:a16="http://schemas.microsoft.com/office/drawing/2014/main" id="{168A022E-0B33-4940-A25E-8F881D86DDB0}"/>
               </a:ext>
             </a:extLst>
           </p:cNvPr>
@@ -4387,7 +4387,7 @@
           <p:cNvPr id="10" name="">
             <a:extLst xmlns:a="http://schemas.openxmlformats.org/drawingml/2006/main">
               <a:ext uri="{FF2B5EF4-FFF2-40B4-BE49-F238E27FC236}">
-                <a16:creationId xmlns:a16="http://schemas.microsoft.com/office/drawing/2014/main" id="{0AE5BC2A-1EBD-4B16-814D-97C0886F0537}"/>
+                <a16:creationId xmlns:a16="http://schemas.microsoft.com/office/drawing/2014/main" id="{80462F87-5859-4E39-A749-EF34FD81EDD3}"/>
               </a:ext>
             </a:extLst>
           </p:cNvPr>
@@ -4418,7 +4418,7 @@
           <p:cNvPr id="11" name="">
             <a:extLst xmlns:a="http://schemas.openxmlformats.org/drawingml/2006/main">
               <a:ext uri="{FF2B5EF4-FFF2-40B4-BE49-F238E27FC236}">
-                <a16:creationId xmlns:a16="http://schemas.microsoft.com/office/drawing/2014/main" id="{48D6BC47-6E63-4BCC-8042-88A6EAB17A92}"/>
+                <a16:creationId xmlns:a16="http://schemas.microsoft.com/office/drawing/2014/main" id="{F8F2ACE7-7A1B-40A6-8FE7-BD254CB2DCEF}"/>
               </a:ext>
             </a:extLst>
           </p:cNvPr>
@@ -4470,7 +4470,7 @@
           <p:cNvPr id="12" name="">
             <a:extLst xmlns:a="http://schemas.openxmlformats.org/drawingml/2006/main">
               <a:ext uri="{FF2B5EF4-FFF2-40B4-BE49-F238E27FC236}">
-                <a16:creationId xmlns:a16="http://schemas.microsoft.com/office/drawing/2014/main" id="{E8F03A34-332D-43A7-A2B9-90869A952070}"/>
+                <a16:creationId xmlns:a16="http://schemas.microsoft.com/office/drawing/2014/main" id="{3F1D5CCA-9EFC-4E11-A55D-981400E9DA59}"/>
               </a:ext>
             </a:extLst>
           </p:cNvPr>
@@ -4539,7 +4539,7 @@
           <p:cNvPr id="13" name="">
             <a:extLst xmlns:a="http://schemas.openxmlformats.org/drawingml/2006/main">
               <a:ext uri="{FF2B5EF4-FFF2-40B4-BE49-F238E27FC236}">
-                <a16:creationId xmlns:a16="http://schemas.microsoft.com/office/drawing/2014/main" id="{41F2B51B-484F-4F09-B91F-0A76B0A48E4A}"/>
+                <a16:creationId xmlns:a16="http://schemas.microsoft.com/office/drawing/2014/main" id="{902B82D2-39C8-4EB4-BA41-4328AD809487}"/>
               </a:ext>
             </a:extLst>
           </p:cNvPr>
@@ -4591,7 +4591,7 @@
           <p:cNvPr id="14" name="">
             <a:extLst xmlns:a="http://schemas.openxmlformats.org/drawingml/2006/main">
               <a:ext uri="{FF2B5EF4-FFF2-40B4-BE49-F238E27FC236}">
-                <a16:creationId xmlns:a16="http://schemas.microsoft.com/office/drawing/2014/main" id="{4E73D6E4-BE7E-4273-B4FF-175CBE7ADCED}"/>
+                <a16:creationId xmlns:a16="http://schemas.microsoft.com/office/drawing/2014/main" id="{DE28A0CA-70EC-4CE4-BEAA-E734EB4BF83B}"/>
               </a:ext>
             </a:extLst>
           </p:cNvPr>
@@ -4632,7 +4632,7 @@
           <p:cNvPr id="15" name="">
             <a:extLst xmlns:a="http://schemas.openxmlformats.org/drawingml/2006/main">
               <a:ext uri="{FF2B5EF4-FFF2-40B4-BE49-F238E27FC236}">
-                <a16:creationId xmlns:a16="http://schemas.microsoft.com/office/drawing/2014/main" id="{047DE1A1-F6B6-4AD5-8B77-F4FA38DD2785}"/>
+                <a16:creationId xmlns:a16="http://schemas.microsoft.com/office/drawing/2014/main" id="{CFADC2EB-1266-4692-A4C2-0C375EB9B986}"/>
               </a:ext>
             </a:extLst>
           </p:cNvPr>
@@ -4663,7 +4663,7 @@
           <p:cNvPr id="16" name="">
             <a:extLst xmlns:a="http://schemas.openxmlformats.org/drawingml/2006/main">
               <a:ext uri="{FF2B5EF4-FFF2-40B4-BE49-F238E27FC236}">
-                <a16:creationId xmlns:a16="http://schemas.microsoft.com/office/drawing/2014/main" id="{C7B13806-E0D5-4500-A02C-0DD25B2DB599}"/>
+                <a16:creationId xmlns:a16="http://schemas.microsoft.com/office/drawing/2014/main" id="{519508C8-4780-4E1A-9CB7-5121D147F598}"/>
               </a:ext>
             </a:extLst>
           </p:cNvPr>
@@ -4715,7 +4715,7 @@
           <p:cNvPr id="17" name="">
             <a:extLst xmlns:a="http://schemas.openxmlformats.org/drawingml/2006/main">
               <a:ext uri="{FF2B5EF4-FFF2-40B4-BE49-F238E27FC236}">
-                <a16:creationId xmlns:a16="http://schemas.microsoft.com/office/drawing/2014/main" id="{19B80E0D-EA25-4C5C-84AB-AA1FE25E88E5}"/>
+                <a16:creationId xmlns:a16="http://schemas.microsoft.com/office/drawing/2014/main" id="{7D99EDC7-D16E-405A-8B42-01D819ECDE03}"/>
               </a:ext>
             </a:extLst>
           </p:cNvPr>
@@ -4767,7 +4767,7 @@
           <p:cNvPr id="18" name="">
             <a:extLst xmlns:a="http://schemas.openxmlformats.org/drawingml/2006/main">
               <a:ext uri="{FF2B5EF4-FFF2-40B4-BE49-F238E27FC236}">
-                <a16:creationId xmlns:a16="http://schemas.microsoft.com/office/drawing/2014/main" id="{D6D5C029-3AC4-4CF1-8F43-971158367258}"/>
+                <a16:creationId xmlns:a16="http://schemas.microsoft.com/office/drawing/2014/main" id="{13F02CB3-1F65-4F9B-AF16-7DAF6AE7B717}"/>
               </a:ext>
             </a:extLst>
           </p:cNvPr>
@@ -4808,7 +4808,7 @@
           <p:cNvPr id="19" name="">
             <a:extLst xmlns:a="http://schemas.openxmlformats.org/drawingml/2006/main">
               <a:ext uri="{FF2B5EF4-FFF2-40B4-BE49-F238E27FC236}">
-                <a16:creationId xmlns:a16="http://schemas.microsoft.com/office/drawing/2014/main" id="{3631EF94-CFA6-46AD-8A48-77B920B04484}"/>
+                <a16:creationId xmlns:a16="http://schemas.microsoft.com/office/drawing/2014/main" id="{C605F30F-E9F3-48CF-A796-2104157DF6DC}"/>
               </a:ext>
             </a:extLst>
           </p:cNvPr>
@@ -4839,7 +4839,7 @@
           <p:cNvPr id="20" name="">
             <a:extLst xmlns:a="http://schemas.openxmlformats.org/drawingml/2006/main">
               <a:ext uri="{FF2B5EF4-FFF2-40B4-BE49-F238E27FC236}">
-                <a16:creationId xmlns:a16="http://schemas.microsoft.com/office/drawing/2014/main" id="{CC333628-B05C-4548-88BE-1F986F89129F}"/>
+                <a16:creationId xmlns:a16="http://schemas.microsoft.com/office/drawing/2014/main" id="{1290EEB4-53B8-4B76-B547-AE78F17C0362}"/>
               </a:ext>
             </a:extLst>
           </p:cNvPr>
@@ -4891,7 +4891,7 @@
           <p:cNvPr id="21" name="">
             <a:extLst xmlns:a="http://schemas.openxmlformats.org/drawingml/2006/main">
               <a:ext uri="{FF2B5EF4-FFF2-40B4-BE49-F238E27FC236}">
-                <a16:creationId xmlns:a16="http://schemas.microsoft.com/office/drawing/2014/main" id="{2005B251-929C-4EEF-B878-EAD17AAAD2D4}"/>
+                <a16:creationId xmlns:a16="http://schemas.microsoft.com/office/drawing/2014/main" id="{9F739B52-82A8-4F2C-A64B-F59B08B21904}"/>
               </a:ext>
             </a:extLst>
           </p:cNvPr>
@@ -4943,7 +4943,7 @@
           <p:cNvPr id="22" name="">
             <a:extLst xmlns:a="http://schemas.openxmlformats.org/drawingml/2006/main">
               <a:ext uri="{FF2B5EF4-FFF2-40B4-BE49-F238E27FC236}">
-                <a16:creationId xmlns:a16="http://schemas.microsoft.com/office/drawing/2014/main" id="{12084DD1-0116-4242-BA54-011A5CE88D77}"/>
+                <a16:creationId xmlns:a16="http://schemas.microsoft.com/office/drawing/2014/main" id="{EEEAF2CA-F2A6-4C01-B4D2-34F73F07A1FD}"/>
               </a:ext>
             </a:extLst>
           </p:cNvPr>
@@ -4984,7 +4984,7 @@
           <p:cNvPr id="23" name="">
             <a:extLst xmlns:a="http://schemas.openxmlformats.org/drawingml/2006/main">
               <a:ext uri="{FF2B5EF4-FFF2-40B4-BE49-F238E27FC236}">
-                <a16:creationId xmlns:a16="http://schemas.microsoft.com/office/drawing/2014/main" id="{3AB49B2D-98F6-45CF-8077-EC0022A9C4D1}"/>
+                <a16:creationId xmlns:a16="http://schemas.microsoft.com/office/drawing/2014/main" id="{8DEC685B-CF85-4DBA-833B-D3490635BB4D}"/>
               </a:ext>
             </a:extLst>
           </p:cNvPr>
@@ -5015,7 +5015,7 @@
           <p:cNvPr id="24" name="">
             <a:extLst xmlns:a="http://schemas.openxmlformats.org/drawingml/2006/main">
               <a:ext uri="{FF2B5EF4-FFF2-40B4-BE49-F238E27FC236}">
-                <a16:creationId xmlns:a16="http://schemas.microsoft.com/office/drawing/2014/main" id="{D3D3521E-03FE-47B5-9520-EA458CD7E042}"/>
+                <a16:creationId xmlns:a16="http://schemas.microsoft.com/office/drawing/2014/main" id="{E7A19FE7-DB0C-4841-B827-F2FD447F7C38}"/>
               </a:ext>
             </a:extLst>
           </p:cNvPr>
@@ -5067,7 +5067,7 @@
           <p:cNvPr id="25" name="">
             <a:extLst xmlns:a="http://schemas.openxmlformats.org/drawingml/2006/main">
               <a:ext uri="{FF2B5EF4-FFF2-40B4-BE49-F238E27FC236}">
-                <a16:creationId xmlns:a16="http://schemas.microsoft.com/office/drawing/2014/main" id="{45230B9C-6A92-4A11-AD2D-577F065C9BC2}"/>
+                <a16:creationId xmlns:a16="http://schemas.microsoft.com/office/drawing/2014/main" id="{BA6F5238-0C0B-4C0C-B384-AB3F722D92E1}"/>
               </a:ext>
             </a:extLst>
           </p:cNvPr>
@@ -5119,7 +5119,7 @@
           <p:cNvPr id="26" name="">
             <a:extLst xmlns:a="http://schemas.openxmlformats.org/drawingml/2006/main">
               <a:ext uri="{FF2B5EF4-FFF2-40B4-BE49-F238E27FC236}">
-                <a16:creationId xmlns:a16="http://schemas.microsoft.com/office/drawing/2014/main" id="{CC4799DB-B19A-4140-A569-58D54E6FF11F}"/>
+                <a16:creationId xmlns:a16="http://schemas.microsoft.com/office/drawing/2014/main" id="{ADA2F58C-A04A-469B-AC02-003D529FF0D7}"/>
               </a:ext>
             </a:extLst>
           </p:cNvPr>
@@ -5171,7 +5171,7 @@
           <p:cNvPr id="27" name="">
             <a:extLst xmlns:a="http://schemas.openxmlformats.org/drawingml/2006/main">
               <a:ext uri="{FF2B5EF4-FFF2-40B4-BE49-F238E27FC236}">
-                <a16:creationId xmlns:a16="http://schemas.microsoft.com/office/drawing/2014/main" id="{70E2234D-9F66-40EF-9052-202D9C431CF4}"/>
+                <a16:creationId xmlns:a16="http://schemas.microsoft.com/office/drawing/2014/main" id="{DBAD55EB-8A27-45F5-A3B0-02A405D7BC4C}"/>
               </a:ext>
             </a:extLst>
           </p:cNvPr>
@@ -5221,7 +5221,7 @@
     </p:spTree>
     <p:extLst>
       <p:ext uri="{BB962C8B-B14F-4D97-AF65-F5344CB8AC3E}">
-        <p14:creationId xmlns:p14="http://schemas.microsoft.com/office/powerpoint/2010/main" val="541559477"/>
+        <p14:creationId xmlns:p14="http://schemas.microsoft.com/office/powerpoint/2010/main" val="1448961444"/>
       </p:ext>
     </p:extLst>
   </p:cSld>
@@ -5256,7 +5256,7 @@
           <p:nvPr/>
         </p:nvPicPr>
         <p:blipFill>
-          <a:blip xmlns:r="http://schemas.openxmlformats.org/officeDocument/2006/relationships" xmlns:a="http://schemas.openxmlformats.org/drawingml/2006/main" r:embed="Rae7c5856edde48d9"/>
+          <a:blip xmlns:r="http://schemas.openxmlformats.org/officeDocument/2006/relationships" xmlns:a="http://schemas.openxmlformats.org/drawingml/2006/main" r:embed="R8929b5cec24f4523"/>
           <a:stretch xmlns:a="http://schemas.openxmlformats.org/drawingml/2006/main"/>
         </p:blipFill>
         <p:spPr>
@@ -5272,7 +5272,7 @@
     </p:spTree>
     <p:extLst>
       <p:ext uri="{BB962C8B-B14F-4D97-AF65-F5344CB8AC3E}">
-        <p14:creationId xmlns:p14="http://schemas.microsoft.com/office/powerpoint/2010/main" val="1038244844"/>
+        <p14:creationId xmlns:p14="http://schemas.microsoft.com/office/powerpoint/2010/main" val="753204754"/>
       </p:ext>
     </p:extLst>
   </p:cSld>
@@ -5303,7 +5303,7 @@
           <p:cNvPr id="9" name="">
             <a:extLst xmlns:a="http://schemas.openxmlformats.org/drawingml/2006/main">
               <a:ext uri="{FF2B5EF4-FFF2-40B4-BE49-F238E27FC236}">
-                <a16:creationId xmlns:a16="http://schemas.microsoft.com/office/drawing/2014/main" id="{1112EA3D-168E-4447-87E4-023D78A440D6}"/>
+                <a16:creationId xmlns:a16="http://schemas.microsoft.com/office/drawing/2014/main" id="{C57A8BA1-49E1-4F2D-9112-3F957ADD52AE}"/>
               </a:ext>
             </a:extLst>
           </p:cNvPr>
@@ -5355,7 +5355,7 @@
           <p:cNvPr id="2" name="">
             <a:extLst xmlns:a="http://schemas.openxmlformats.org/drawingml/2006/main">
               <a:ext uri="{FF2B5EF4-FFF2-40B4-BE49-F238E27FC236}">
-                <a16:creationId xmlns:a16="http://schemas.microsoft.com/office/drawing/2014/main" id="{78680AD9-646F-475B-9B3E-258BA950A657}"/>
+                <a16:creationId xmlns:a16="http://schemas.microsoft.com/office/drawing/2014/main" id="{CE4A3EA8-7177-4F9B-86DC-38B4AAF8F017}"/>
               </a:ext>
             </a:extLst>
           </p:cNvPr>
@@ -5386,7 +5386,7 @@
           <p:cNvPr id="3" name="">
             <a:extLst xmlns:a="http://schemas.openxmlformats.org/drawingml/2006/main">
               <a:ext uri="{FF2B5EF4-FFF2-40B4-BE49-F238E27FC236}">
-                <a16:creationId xmlns:a16="http://schemas.microsoft.com/office/drawing/2014/main" id="{F2C7E6E6-19F2-43E7-AB61-4777B24628D7}"/>
+                <a16:creationId xmlns:a16="http://schemas.microsoft.com/office/drawing/2014/main" id="{B1A5CAF5-EE6A-40AE-82DB-D5C29C4210E5}"/>
               </a:ext>
             </a:extLst>
           </p:cNvPr>
@@ -5438,7 +5438,7 @@
           <p:cNvPr id="4" name="">
             <a:extLst xmlns:a="http://schemas.openxmlformats.org/drawingml/2006/main">
               <a:ext uri="{FF2B5EF4-FFF2-40B4-BE49-F238E27FC236}">
-                <a16:creationId xmlns:a16="http://schemas.microsoft.com/office/drawing/2014/main" id="{3F4523E6-2B16-4145-B5C2-E1F2695E03CA}"/>
+                <a16:creationId xmlns:a16="http://schemas.microsoft.com/office/drawing/2014/main" id="{EE522298-5411-401A-8E8D-F82000EB8B4E}"/>
               </a:ext>
             </a:extLst>
           </p:cNvPr>
@@ -5479,7 +5479,7 @@
           <p:cNvPr id="5" name="">
             <a:extLst xmlns:a="http://schemas.openxmlformats.org/drawingml/2006/main">
               <a:ext uri="{FF2B5EF4-FFF2-40B4-BE49-F238E27FC236}">
-                <a16:creationId xmlns:a16="http://schemas.microsoft.com/office/drawing/2014/main" id="{06F31908-1EC3-4F59-84DC-746C554C58E8}"/>
+                <a16:creationId xmlns:a16="http://schemas.microsoft.com/office/drawing/2014/main" id="{F9B6DACD-4A30-4556-BE50-4678EB012582}"/>
               </a:ext>
             </a:extLst>
           </p:cNvPr>
@@ -5510,7 +5510,7 @@
           <p:cNvPr id="6" name="">
             <a:extLst xmlns:a="http://schemas.openxmlformats.org/drawingml/2006/main">
               <a:ext uri="{FF2B5EF4-FFF2-40B4-BE49-F238E27FC236}">
-                <a16:creationId xmlns:a16="http://schemas.microsoft.com/office/drawing/2014/main" id="{5C4AB65E-0E49-4899-A3A8-F385C76600E7}"/>
+                <a16:creationId xmlns:a16="http://schemas.microsoft.com/office/drawing/2014/main" id="{D5062EA1-6FE7-4050-8B94-59B91FBF2D7F}"/>
               </a:ext>
             </a:extLst>
           </p:cNvPr>
@@ -5562,7 +5562,7 @@
           <p:cNvPr id="7" name="">
             <a:extLst xmlns:a="http://schemas.openxmlformats.org/drawingml/2006/main">
               <a:ext uri="{FF2B5EF4-FFF2-40B4-BE49-F238E27FC236}">
-                <a16:creationId xmlns:a16="http://schemas.microsoft.com/office/drawing/2014/main" id="{A5BB0542-5067-400C-B496-6B444068F009}"/>
+                <a16:creationId xmlns:a16="http://schemas.microsoft.com/office/drawing/2014/main" id="{0EB76D04-1F1D-4FEF-BAEC-C03F9CB27C6A}"/>
               </a:ext>
             </a:extLst>
           </p:cNvPr>
@@ -5702,7 +5702,7 @@
           <p:cNvPr id="8" name="">
             <a:extLst xmlns:a="http://schemas.openxmlformats.org/drawingml/2006/main">
               <a:ext uri="{FF2B5EF4-FFF2-40B4-BE49-F238E27FC236}">
-                <a16:creationId xmlns:a16="http://schemas.microsoft.com/office/drawing/2014/main" id="{75C9A2C2-93F6-440F-A438-80995FB3897C}"/>
+                <a16:creationId xmlns:a16="http://schemas.microsoft.com/office/drawing/2014/main" id="{A24B3178-75E4-48E6-8364-6979F7DF38DE}"/>
               </a:ext>
             </a:extLst>
           </p:cNvPr>
@@ -5752,7 +5752,7 @@
     </p:spTree>
     <p:extLst>
       <p:ext uri="{BB962C8B-B14F-4D97-AF65-F5344CB8AC3E}">
-        <p14:creationId xmlns:p14="http://schemas.microsoft.com/office/powerpoint/2010/main" val="1866725604"/>
+        <p14:creationId xmlns:p14="http://schemas.microsoft.com/office/powerpoint/2010/main" val="1222622820"/>
       </p:ext>
     </p:extLst>
   </p:cSld>
@@ -5783,7 +5783,7 @@
           <p:cNvPr id="18" name="">
             <a:extLst xmlns:a="http://schemas.openxmlformats.org/drawingml/2006/main">
               <a:ext uri="{FF2B5EF4-FFF2-40B4-BE49-F238E27FC236}">
-                <a16:creationId xmlns:a16="http://schemas.microsoft.com/office/drawing/2014/main" id="{F70A24D5-752D-4B22-83B2-6F19409C28B3}"/>
+                <a16:creationId xmlns:a16="http://schemas.microsoft.com/office/drawing/2014/main" id="{F542F316-0804-46F8-B47F-42E0F2BF8FD1}"/>
               </a:ext>
             </a:extLst>
           </p:cNvPr>
@@ -5835,7 +5835,7 @@
           <p:cNvPr id="2" name="">
             <a:extLst xmlns:a="http://schemas.openxmlformats.org/drawingml/2006/main">
               <a:ext uri="{FF2B5EF4-FFF2-40B4-BE49-F238E27FC236}">
-                <a16:creationId xmlns:a16="http://schemas.microsoft.com/office/drawing/2014/main" id="{94E910EF-6E4C-419A-9B14-29DAEAD480CD}"/>
+                <a16:creationId xmlns:a16="http://schemas.microsoft.com/office/drawing/2014/main" id="{F04CBC84-A717-44A9-A422-5800EE1A2231}"/>
               </a:ext>
             </a:extLst>
           </p:cNvPr>
@@ -5866,7 +5866,7 @@
           <p:cNvPr id="3" name="">
             <a:extLst xmlns:a="http://schemas.openxmlformats.org/drawingml/2006/main">
               <a:ext uri="{FF2B5EF4-FFF2-40B4-BE49-F238E27FC236}">
-                <a16:creationId xmlns:a16="http://schemas.microsoft.com/office/drawing/2014/main" id="{A09A42B5-437E-4710-A899-2742FC2AF137}"/>
+                <a16:creationId xmlns:a16="http://schemas.microsoft.com/office/drawing/2014/main" id="{67BED3CD-EF89-451A-B13C-0FF6F1E8C112}"/>
               </a:ext>
             </a:extLst>
           </p:cNvPr>
@@ -5918,7 +5918,7 @@
           <p:cNvPr id="4" name="">
             <a:extLst xmlns:a="http://schemas.openxmlformats.org/drawingml/2006/main">
               <a:ext uri="{FF2B5EF4-FFF2-40B4-BE49-F238E27FC236}">
-                <a16:creationId xmlns:a16="http://schemas.microsoft.com/office/drawing/2014/main" id="{3B12E3AB-8C51-4D99-9381-5BA394BADD2F}"/>
+                <a16:creationId xmlns:a16="http://schemas.microsoft.com/office/drawing/2014/main" id="{15A51F22-5B81-4C30-854F-19904EE8C973}"/>
               </a:ext>
             </a:extLst>
           </p:cNvPr>
@@ -5959,7 +5959,7 @@
           <p:cNvPr id="5" name="">
             <a:extLst xmlns:a="http://schemas.openxmlformats.org/drawingml/2006/main">
               <a:ext uri="{FF2B5EF4-FFF2-40B4-BE49-F238E27FC236}">
-                <a16:creationId xmlns:a16="http://schemas.microsoft.com/office/drawing/2014/main" id="{F7ABD8A3-3BEE-459F-9862-554A868C51CE}"/>
+                <a16:creationId xmlns:a16="http://schemas.microsoft.com/office/drawing/2014/main" id="{ABAC8FC7-8FD7-4DD6-BFBB-C62D20F052E0}"/>
               </a:ext>
             </a:extLst>
           </p:cNvPr>
@@ -5990,7 +5990,7 @@
           <p:cNvPr id="6" name="">
             <a:extLst xmlns:a="http://schemas.openxmlformats.org/drawingml/2006/main">
               <a:ext uri="{FF2B5EF4-FFF2-40B4-BE49-F238E27FC236}">
-                <a16:creationId xmlns:a16="http://schemas.microsoft.com/office/drawing/2014/main" id="{AC423C99-4796-419B-96B9-6057452C6728}"/>
+                <a16:creationId xmlns:a16="http://schemas.microsoft.com/office/drawing/2014/main" id="{8FB41A44-5183-4CA8-9C06-B68CCD955290}"/>
               </a:ext>
             </a:extLst>
           </p:cNvPr>
@@ -6042,7 +6042,7 @@
           <p:cNvPr id="7" name="">
             <a:extLst xmlns:a="http://schemas.openxmlformats.org/drawingml/2006/main">
               <a:ext uri="{FF2B5EF4-FFF2-40B4-BE49-F238E27FC236}">
-                <a16:creationId xmlns:a16="http://schemas.microsoft.com/office/drawing/2014/main" id="{17C4D416-FE91-4AE2-8AF5-FDAECC027CD1}"/>
+                <a16:creationId xmlns:a16="http://schemas.microsoft.com/office/drawing/2014/main" id="{4A3C3BCB-5D65-4CBF-976F-872BC0FC2F0D}"/>
               </a:ext>
             </a:extLst>
           </p:cNvPr>
@@ -6094,7 +6094,7 @@
           <p:cNvPr id="8" name="">
             <a:extLst xmlns:a="http://schemas.openxmlformats.org/drawingml/2006/main">
               <a:ext uri="{FF2B5EF4-FFF2-40B4-BE49-F238E27FC236}">
-                <a16:creationId xmlns:a16="http://schemas.microsoft.com/office/drawing/2014/main" id="{29178CCB-4F8B-4DD3-83BD-59D8ABC0C461}"/>
+                <a16:creationId xmlns:a16="http://schemas.microsoft.com/office/drawing/2014/main" id="{2701CE4F-09E7-47FB-A466-96847BC23A8D}"/>
               </a:ext>
             </a:extLst>
           </p:cNvPr>
@@ -6135,7 +6135,7 @@
           <p:cNvPr id="9" name="">
             <a:extLst xmlns:a="http://schemas.openxmlformats.org/drawingml/2006/main">
               <a:ext uri="{FF2B5EF4-FFF2-40B4-BE49-F238E27FC236}">
-                <a16:creationId xmlns:a16="http://schemas.microsoft.com/office/drawing/2014/main" id="{A6CC6E52-BF0F-4061-B3B5-0D80C29A471E}"/>
+                <a16:creationId xmlns:a16="http://schemas.microsoft.com/office/drawing/2014/main" id="{D17D89C8-E3A1-4480-9D80-77747AB4AEAF}"/>
               </a:ext>
             </a:extLst>
           </p:cNvPr>
@@ -6166,7 +6166,7 @@
           <p:cNvPr id="10" name="">
             <a:extLst xmlns:a="http://schemas.openxmlformats.org/drawingml/2006/main">
               <a:ext uri="{FF2B5EF4-FFF2-40B4-BE49-F238E27FC236}">
-                <a16:creationId xmlns:a16="http://schemas.microsoft.com/office/drawing/2014/main" id="{AC2D2562-521F-4247-AAFA-21A81CE8B7C4}"/>
+                <a16:creationId xmlns:a16="http://schemas.microsoft.com/office/drawing/2014/main" id="{8E418617-9445-4443-9111-83A03AE8C1BA}"/>
               </a:ext>
             </a:extLst>
           </p:cNvPr>
@@ -6218,7 +6218,7 @@
           <p:cNvPr id="11" name="">
             <a:extLst xmlns:a="http://schemas.openxmlformats.org/drawingml/2006/main">
               <a:ext uri="{FF2B5EF4-FFF2-40B4-BE49-F238E27FC236}">
-                <a16:creationId xmlns:a16="http://schemas.microsoft.com/office/drawing/2014/main" id="{84BBA410-61AF-49B6-A348-106C7F8FB9CB}"/>
+                <a16:creationId xmlns:a16="http://schemas.microsoft.com/office/drawing/2014/main" id="{D8DF4576-53C1-4A5C-BFD1-0BC93577CC49}"/>
               </a:ext>
             </a:extLst>
           </p:cNvPr>
@@ -6270,7 +6270,7 @@
           <p:cNvPr id="12" name="">
             <a:extLst xmlns:a="http://schemas.openxmlformats.org/drawingml/2006/main">
               <a:ext uri="{FF2B5EF4-FFF2-40B4-BE49-F238E27FC236}">
-                <a16:creationId xmlns:a16="http://schemas.microsoft.com/office/drawing/2014/main" id="{CE83E6B7-4E38-4F63-902D-9E8CB12B94F6}"/>
+                <a16:creationId xmlns:a16="http://schemas.microsoft.com/office/drawing/2014/main" id="{92B5880C-8AB5-4B16-A9F5-55E81CE86BCE}"/>
               </a:ext>
             </a:extLst>
           </p:cNvPr>
@@ -6311,7 +6311,7 @@
           <p:cNvPr id="13" name="">
             <a:extLst xmlns:a="http://schemas.openxmlformats.org/drawingml/2006/main">
               <a:ext uri="{FF2B5EF4-FFF2-40B4-BE49-F238E27FC236}">
-                <a16:creationId xmlns:a16="http://schemas.microsoft.com/office/drawing/2014/main" id="{C704A165-66E5-4F6C-8085-48E982515330}"/>
+                <a16:creationId xmlns:a16="http://schemas.microsoft.com/office/drawing/2014/main" id="{F20DB98B-2E3E-43C5-B5EC-0E930033CF5F}"/>
               </a:ext>
             </a:extLst>
           </p:cNvPr>
@@ -6342,7 +6342,7 @@
           <p:cNvPr id="14" name="">
             <a:extLst xmlns:a="http://schemas.openxmlformats.org/drawingml/2006/main">
               <a:ext uri="{FF2B5EF4-FFF2-40B4-BE49-F238E27FC236}">
-                <a16:creationId xmlns:a16="http://schemas.microsoft.com/office/drawing/2014/main" id="{5A88438D-AFDE-496E-A465-CEC5434CBFAC}"/>
+                <a16:creationId xmlns:a16="http://schemas.microsoft.com/office/drawing/2014/main" id="{499EF1C1-72E6-4736-8E59-50DEA0862820}"/>
               </a:ext>
             </a:extLst>
           </p:cNvPr>
@@ -6394,7 +6394,7 @@
           <p:cNvPr id="15" name="">
             <a:extLst xmlns:a="http://schemas.openxmlformats.org/drawingml/2006/main">
               <a:ext uri="{FF2B5EF4-FFF2-40B4-BE49-F238E27FC236}">
-                <a16:creationId xmlns:a16="http://schemas.microsoft.com/office/drawing/2014/main" id="{50DB3073-93C1-44CB-A81A-235ACDA8ADA3}"/>
+                <a16:creationId xmlns:a16="http://schemas.microsoft.com/office/drawing/2014/main" id="{6A99C069-2861-4C5E-AEC0-46A306BA4041}"/>
               </a:ext>
             </a:extLst>
           </p:cNvPr>
@@ -6446,7 +6446,7 @@
           <p:cNvPr id="16" name="">
             <a:extLst xmlns:a="http://schemas.openxmlformats.org/drawingml/2006/main">
               <a:ext uri="{FF2B5EF4-FFF2-40B4-BE49-F238E27FC236}">
-                <a16:creationId xmlns:a16="http://schemas.microsoft.com/office/drawing/2014/main" id="{E9B272CA-C86D-4C8C-BB3A-17B614A1DB19}"/>
+                <a16:creationId xmlns:a16="http://schemas.microsoft.com/office/drawing/2014/main" id="{FFCA3633-84D2-4587-B39D-7A392909576C}"/>
               </a:ext>
             </a:extLst>
           </p:cNvPr>
@@ -6515,7 +6515,7 @@
           <p:cNvPr id="17" name="">
             <a:extLst xmlns:a="http://schemas.openxmlformats.org/drawingml/2006/main">
               <a:ext uri="{FF2B5EF4-FFF2-40B4-BE49-F238E27FC236}">
-                <a16:creationId xmlns:a16="http://schemas.microsoft.com/office/drawing/2014/main" id="{2E75DBE1-7CAC-4CF0-B221-9DE454708A31}"/>
+                <a16:creationId xmlns:a16="http://schemas.microsoft.com/office/drawing/2014/main" id="{1AEF3335-0568-4366-95C3-C32B165DB9F9}"/>
               </a:ext>
             </a:extLst>
           </p:cNvPr>
@@ -6565,7 +6565,7 @@
     </p:spTree>
     <p:extLst>
       <p:ext uri="{BB962C8B-B14F-4D97-AF65-F5344CB8AC3E}">
-        <p14:creationId xmlns:p14="http://schemas.microsoft.com/office/powerpoint/2010/main" val="1271255339"/>
+        <p14:creationId xmlns:p14="http://schemas.microsoft.com/office/powerpoint/2010/main" val="143160653"/>
       </p:ext>
     </p:extLst>
   </p:cSld>
@@ -6596,7 +6596,7 @@
           <p:cNvPr id="13" name="">
             <a:extLst xmlns:a="http://schemas.openxmlformats.org/drawingml/2006/main">
               <a:ext uri="{FF2B5EF4-FFF2-40B4-BE49-F238E27FC236}">
-                <a16:creationId xmlns:a16="http://schemas.microsoft.com/office/drawing/2014/main" id="{0290512B-43B3-47EA-8B8F-A06DC59CBC33}"/>
+                <a16:creationId xmlns:a16="http://schemas.microsoft.com/office/drawing/2014/main" id="{E282B47C-2EEF-4967-87D6-4E166308BECE}"/>
               </a:ext>
             </a:extLst>
           </p:cNvPr>
@@ -6648,7 +6648,7 @@
           <p:cNvPr id="2" name="">
             <a:extLst xmlns:a="http://schemas.openxmlformats.org/drawingml/2006/main">
               <a:ext uri="{FF2B5EF4-FFF2-40B4-BE49-F238E27FC236}">
-                <a16:creationId xmlns:a16="http://schemas.microsoft.com/office/drawing/2014/main" id="{A9B3BB70-3FFA-4487-88AA-3A2D30E57CF8}"/>
+                <a16:creationId xmlns:a16="http://schemas.microsoft.com/office/drawing/2014/main" id="{710BAAD4-4359-4EBE-8890-B75293BFE83A}"/>
               </a:ext>
             </a:extLst>
           </p:cNvPr>
@@ -6679,7 +6679,7 @@
           <p:cNvPr id="3" name="">
             <a:extLst xmlns:a="http://schemas.openxmlformats.org/drawingml/2006/main">
               <a:ext uri="{FF2B5EF4-FFF2-40B4-BE49-F238E27FC236}">
-                <a16:creationId xmlns:a16="http://schemas.microsoft.com/office/drawing/2014/main" id="{E91F16F7-C9EE-4728-834E-CE73E2A13F09}"/>
+                <a16:creationId xmlns:a16="http://schemas.microsoft.com/office/drawing/2014/main" id="{D2190799-39FD-4B6C-BCFF-2B7DBA948359}"/>
               </a:ext>
             </a:extLst>
           </p:cNvPr>
@@ -6731,7 +6731,7 @@
           <p:cNvPr id="4" name="">
             <a:extLst xmlns:a="http://schemas.openxmlformats.org/drawingml/2006/main">
               <a:ext uri="{FF2B5EF4-FFF2-40B4-BE49-F238E27FC236}">
-                <a16:creationId xmlns:a16="http://schemas.microsoft.com/office/drawing/2014/main" id="{12DB961F-E22B-4A6A-AE8E-BD08491FC003}"/>
+                <a16:creationId xmlns:a16="http://schemas.microsoft.com/office/drawing/2014/main" id="{C58A30E6-2F34-4E21-A327-7D17432E3962}"/>
               </a:ext>
             </a:extLst>
           </p:cNvPr>
@@ -6772,7 +6772,7 @@
           <p:cNvPr id="5" name="">
             <a:extLst xmlns:a="http://schemas.openxmlformats.org/drawingml/2006/main">
               <a:ext uri="{FF2B5EF4-FFF2-40B4-BE49-F238E27FC236}">
-                <a16:creationId xmlns:a16="http://schemas.microsoft.com/office/drawing/2014/main" id="{7500F446-0A96-44ED-91CC-C8F22076D666}"/>
+                <a16:creationId xmlns:a16="http://schemas.microsoft.com/office/drawing/2014/main" id="{08FC84F8-361B-41C9-8133-EEBB0318E0C8}"/>
               </a:ext>
             </a:extLst>
           </p:cNvPr>
@@ -6803,7 +6803,7 @@
           <p:cNvPr id="6" name="">
             <a:extLst xmlns:a="http://schemas.openxmlformats.org/drawingml/2006/main">
               <a:ext uri="{FF2B5EF4-FFF2-40B4-BE49-F238E27FC236}">
-                <a16:creationId xmlns:a16="http://schemas.microsoft.com/office/drawing/2014/main" id="{68152AC5-7DF4-4EEE-8BF5-07766EA16AD7}"/>
+                <a16:creationId xmlns:a16="http://schemas.microsoft.com/office/drawing/2014/main" id="{60B0E53C-E3CE-4587-A09E-6DCEEF673877}"/>
               </a:ext>
             </a:extLst>
           </p:cNvPr>
@@ -6845,7 +6845,7 @@
                   <a:srgbClr val="143B5D"/>
                 </a:solidFill>
               </a:rPr>
-              <a:t>Igualdade formal</a:t>
+              <a:t>Igualdade formal na OMC</a:t>
             </a:r>
           </a:p>
         </p:txBody>
@@ -6855,7 +6855,7 @@
           <p:cNvPr id="7" name="">
             <a:extLst xmlns:a="http://schemas.openxmlformats.org/drawingml/2006/main">
               <a:ext uri="{FF2B5EF4-FFF2-40B4-BE49-F238E27FC236}">
-                <a16:creationId xmlns:a16="http://schemas.microsoft.com/office/drawing/2014/main" id="{C08F51FF-59ED-4397-BBC6-B0FD759E1F3E}"/>
+                <a16:creationId xmlns:a16="http://schemas.microsoft.com/office/drawing/2014/main" id="{9DFC56BE-B8A1-492E-9FAD-21920C0D5D9E}"/>
               </a:ext>
             </a:extLst>
           </p:cNvPr>
@@ -6897,7 +6897,12 @@
                   <a:srgbClr val="17212B"/>
                 </a:solidFill>
               </a:rPr>
-              <a:t>• Primeiro, consenso.</a:t>
+              <a:t>Duas fontes de igualdade:</a:t>
+            </a:r>
+          </a:p>
+          <a:p xmlns:a="http://schemas.openxmlformats.org/drawingml/2006/main">
+            <a:r>
+              <a:t/>
             </a:r>
           </a:p>
           <a:p xmlns:a="http://schemas.openxmlformats.org/drawingml/2006/main">
@@ -6914,7 +6919,12 @@
                   <a:srgbClr val="17212B"/>
                 </a:solidFill>
               </a:rPr>
-              <a:t>• Se não houver consenso, votação.</a:t>
+              <a:t>• O consenso implica que todos possuem igual poder de veto.</a:t>
+            </a:r>
+          </a:p>
+          <a:p xmlns:a="http://schemas.openxmlformats.org/drawingml/2006/main">
+            <a:r>
+              <a:t/>
             </a:r>
           </a:p>
           <a:p xmlns:a="http://schemas.openxmlformats.org/drawingml/2006/main">
@@ -6931,29 +6941,7 @@
                   <a:srgbClr val="17212B"/>
                 </a:solidFill>
               </a:rPr>
-              <a:t>• Cada membro tem um voto.</a:t>
-            </a:r>
-          </a:p>
-          <a:p xmlns:a="http://schemas.openxmlformats.org/drawingml/2006/main">
-            <a:r>
-              <a:t/>
-            </a:r>
-          </a:p>
-          <a:p xmlns:a="http://schemas.openxmlformats.org/drawingml/2006/main">
-            <a:pPr algn="l">
-              <a:defRPr sz="1425" b="0">
-                <a:solidFill>
-                  <a:srgbClr val="17212B"/>
-                </a:solidFill>
-              </a:defRPr>
-            </a:pPr>
-            <a:r>
-              <a:rPr sz="1425" b="0">
-                <a:solidFill>
-                  <a:srgbClr val="17212B"/>
-                </a:solidFill>
-              </a:rPr>
-              <a:t>Mas os Estados Unidos continuam capazes de moldar resultados.</a:t>
+              <a:t>• Não há controle formal de agenda por nenhum agente.</a:t>
             </a:r>
           </a:p>
         </p:txBody>
@@ -6963,7 +6951,7 @@
           <p:cNvPr id="8" name="">
             <a:extLst xmlns:a="http://schemas.openxmlformats.org/drawingml/2006/main">
               <a:ext uri="{FF2B5EF4-FFF2-40B4-BE49-F238E27FC236}">
-                <a16:creationId xmlns:a16="http://schemas.microsoft.com/office/drawing/2014/main" id="{665E89BB-48EF-4C92-ADE2-1501946CA88B}"/>
+                <a16:creationId xmlns:a16="http://schemas.microsoft.com/office/drawing/2014/main" id="{04180537-C0AC-4597-A195-4C95C816537C}"/>
               </a:ext>
             </a:extLst>
           </p:cNvPr>
@@ -7004,7 +6992,7 @@
           <p:cNvPr id="9" name="">
             <a:extLst xmlns:a="http://schemas.openxmlformats.org/drawingml/2006/main">
               <a:ext uri="{FF2B5EF4-FFF2-40B4-BE49-F238E27FC236}">
-                <a16:creationId xmlns:a16="http://schemas.microsoft.com/office/drawing/2014/main" id="{6C468053-39DE-412E-A250-E2C6329B71B0}"/>
+                <a16:creationId xmlns:a16="http://schemas.microsoft.com/office/drawing/2014/main" id="{7E62C60E-D51D-4440-9A95-570EA79B5E2A}"/>
               </a:ext>
             </a:extLst>
           </p:cNvPr>
@@ -7035,7 +7023,7 @@
           <p:cNvPr id="10" name="">
             <a:extLst xmlns:a="http://schemas.openxmlformats.org/drawingml/2006/main">
               <a:ext uri="{FF2B5EF4-FFF2-40B4-BE49-F238E27FC236}">
-                <a16:creationId xmlns:a16="http://schemas.microsoft.com/office/drawing/2014/main" id="{6F22E708-D54F-435B-8F93-02B8ACC7BE48}"/>
+                <a16:creationId xmlns:a16="http://schemas.microsoft.com/office/drawing/2014/main" id="{9F644C30-85E3-4C15-8FC5-A27CA6780F15}"/>
               </a:ext>
             </a:extLst>
           </p:cNvPr>
@@ -7087,7 +7075,7 @@
           <p:cNvPr id="11" name="">
             <a:extLst xmlns:a="http://schemas.openxmlformats.org/drawingml/2006/main">
               <a:ext uri="{FF2B5EF4-FFF2-40B4-BE49-F238E27FC236}">
-                <a16:creationId xmlns:a16="http://schemas.microsoft.com/office/drawing/2014/main" id="{34D33BBB-919D-4704-B878-A3EEFBA2725E}"/>
+                <a16:creationId xmlns:a16="http://schemas.microsoft.com/office/drawing/2014/main" id="{A36AB4C8-5F51-4F48-84A7-6C6E83FA049B}"/>
               </a:ext>
             </a:extLst>
           </p:cNvPr>
@@ -7129,7 +7117,7 @@
                   <a:srgbClr val="17212B"/>
                 </a:solidFill>
               </a:rPr>
-              <a:t>Quando o tipo de baixa exigência pode obter mais sob consenso do que sob maioria?</a:t>
+              <a:t>Como assimetria de poder no SI é consistente com igualdade formal em uma IO?</a:t>
             </a:r>
           </a:p>
         </p:txBody>
@@ -7139,7 +7127,7 @@
           <p:cNvPr id="12" name="">
             <a:extLst xmlns:a="http://schemas.openxmlformats.org/drawingml/2006/main">
               <a:ext uri="{FF2B5EF4-FFF2-40B4-BE49-F238E27FC236}">
-                <a16:creationId xmlns:a16="http://schemas.microsoft.com/office/drawing/2014/main" id="{AB7343E5-686A-4D08-8079-AE6E383F5069}"/>
+                <a16:creationId xmlns:a16="http://schemas.microsoft.com/office/drawing/2014/main" id="{E609423D-7AD6-4771-82AE-1913DC16724F}"/>
               </a:ext>
             </a:extLst>
           </p:cNvPr>
@@ -7189,7 +7177,7 @@
     </p:spTree>
     <p:extLst>
       <p:ext uri="{BB962C8B-B14F-4D97-AF65-F5344CB8AC3E}">
-        <p14:creationId xmlns:p14="http://schemas.microsoft.com/office/powerpoint/2010/main" val="551040907"/>
+        <p14:creationId xmlns:p14="http://schemas.microsoft.com/office/powerpoint/2010/main" val="1611916905"/>
       </p:ext>
     </p:extLst>
   </p:cSld>
@@ -7220,7 +7208,7 @@
           <p:cNvPr id="18" name="">
             <a:extLst xmlns:a="http://schemas.openxmlformats.org/drawingml/2006/main">
               <a:ext uri="{FF2B5EF4-FFF2-40B4-BE49-F238E27FC236}">
-                <a16:creationId xmlns:a16="http://schemas.microsoft.com/office/drawing/2014/main" id="{F5D46792-84A7-4CA7-A174-C39F6FAB6197}"/>
+                <a16:creationId xmlns:a16="http://schemas.microsoft.com/office/drawing/2014/main" id="{0E56336B-2C35-4FBB-8671-BC82528026FC}"/>
               </a:ext>
             </a:extLst>
           </p:cNvPr>
@@ -7272,7 +7260,7 @@
           <p:cNvPr id="2" name="">
             <a:extLst xmlns:a="http://schemas.openxmlformats.org/drawingml/2006/main">
               <a:ext uri="{FF2B5EF4-FFF2-40B4-BE49-F238E27FC236}">
-                <a16:creationId xmlns:a16="http://schemas.microsoft.com/office/drawing/2014/main" id="{03716FD3-E884-4893-93CC-69D7FB8AF4C0}"/>
+                <a16:creationId xmlns:a16="http://schemas.microsoft.com/office/drawing/2014/main" id="{E8FF22AD-3395-440D-BCD7-8BF8827718BF}"/>
               </a:ext>
             </a:extLst>
           </p:cNvPr>
@@ -7303,7 +7291,7 @@
           <p:cNvPr id="3" name="">
             <a:extLst xmlns:a="http://schemas.openxmlformats.org/drawingml/2006/main">
               <a:ext uri="{FF2B5EF4-FFF2-40B4-BE49-F238E27FC236}">
-                <a16:creationId xmlns:a16="http://schemas.microsoft.com/office/drawing/2014/main" id="{9232154F-887A-4C30-A628-B7195DB470DB}"/>
+                <a16:creationId xmlns:a16="http://schemas.microsoft.com/office/drawing/2014/main" id="{69E4B556-FDDC-4431-B5FB-983B5B1B9462}"/>
               </a:ext>
             </a:extLst>
           </p:cNvPr>
@@ -7355,7 +7343,7 @@
           <p:cNvPr id="4" name="">
             <a:extLst xmlns:a="http://schemas.openxmlformats.org/drawingml/2006/main">
               <a:ext uri="{FF2B5EF4-FFF2-40B4-BE49-F238E27FC236}">
-                <a16:creationId xmlns:a16="http://schemas.microsoft.com/office/drawing/2014/main" id="{755F95B2-DBD3-44D7-B498-3D459034C474}"/>
+                <a16:creationId xmlns:a16="http://schemas.microsoft.com/office/drawing/2014/main" id="{2DFFC4ED-77F2-48EE-AD76-070A9DBCD3D6}"/>
               </a:ext>
             </a:extLst>
           </p:cNvPr>
@@ -7396,7 +7384,7 @@
           <p:cNvPr id="5" name="">
             <a:extLst xmlns:a="http://schemas.openxmlformats.org/drawingml/2006/main">
               <a:ext uri="{FF2B5EF4-FFF2-40B4-BE49-F238E27FC236}">
-                <a16:creationId xmlns:a16="http://schemas.microsoft.com/office/drawing/2014/main" id="{B3A8B240-8E45-49CE-859A-063E8FBB2165}"/>
+                <a16:creationId xmlns:a16="http://schemas.microsoft.com/office/drawing/2014/main" id="{6558AB60-76EA-4879-88AF-118D19B8D3FB}"/>
               </a:ext>
             </a:extLst>
           </p:cNvPr>
@@ -7427,7 +7415,7 @@
           <p:cNvPr id="6" name="">
             <a:extLst xmlns:a="http://schemas.openxmlformats.org/drawingml/2006/main">
               <a:ext uri="{FF2B5EF4-FFF2-40B4-BE49-F238E27FC236}">
-                <a16:creationId xmlns:a16="http://schemas.microsoft.com/office/drawing/2014/main" id="{FBA67AAA-6C0B-472F-AE66-70DE457F40C6}"/>
+                <a16:creationId xmlns:a16="http://schemas.microsoft.com/office/drawing/2014/main" id="{77F65DF0-D693-43BA-A8B7-3138466C9D57}"/>
               </a:ext>
             </a:extLst>
           </p:cNvPr>
@@ -7469,7 +7457,7 @@
                   <a:srgbClr val="143B5D"/>
                 </a:solidFill>
               </a:rPr>
-              <a:t>Agenda e informação</a:t>
+              <a:t>Agenda informal</a:t>
             </a:r>
           </a:p>
         </p:txBody>
@@ -7479,7 +7467,7 @@
           <p:cNvPr id="7" name="">
             <a:extLst xmlns:a="http://schemas.openxmlformats.org/drawingml/2006/main">
               <a:ext uri="{FF2B5EF4-FFF2-40B4-BE49-F238E27FC236}">
-                <a16:creationId xmlns:a16="http://schemas.microsoft.com/office/drawing/2014/main" id="{1EABC34C-5FA0-404C-BFCC-230A496AD0A1}"/>
+                <a16:creationId xmlns:a16="http://schemas.microsoft.com/office/drawing/2014/main" id="{DF7FD8BB-1319-491C-BDE7-F99DD5D088AF}"/>
               </a:ext>
             </a:extLst>
           </p:cNvPr>
@@ -7521,7 +7509,7 @@
                   <a:srgbClr val="17212B"/>
                 </a:solidFill>
               </a:rPr>
-              <a:t>Controle do texto, do timing e das alternativas; aprendizado sobre as restrições dos fracos.</a:t>
+              <a:t>Controle de agenda informal; timing, alternativas e negociação antes da aprovação.</a:t>
             </a:r>
           </a:p>
         </p:txBody>
@@ -7531,7 +7519,7 @@
           <p:cNvPr id="8" name="">
             <a:extLst xmlns:a="http://schemas.openxmlformats.org/drawingml/2006/main">
               <a:ext uri="{FF2B5EF4-FFF2-40B4-BE49-F238E27FC236}">
-                <a16:creationId xmlns:a16="http://schemas.microsoft.com/office/drawing/2014/main" id="{58E1F18E-E4D4-4E18-B000-36823D73D690}"/>
+                <a16:creationId xmlns:a16="http://schemas.microsoft.com/office/drawing/2014/main" id="{89BD37E6-3CCB-4FF6-A7EA-28365B30F763}"/>
               </a:ext>
             </a:extLst>
           </p:cNvPr>
@@ -7572,7 +7560,7 @@
           <p:cNvPr id="9" name="">
             <a:extLst xmlns:a="http://schemas.openxmlformats.org/drawingml/2006/main">
               <a:ext uri="{FF2B5EF4-FFF2-40B4-BE49-F238E27FC236}">
-                <a16:creationId xmlns:a16="http://schemas.microsoft.com/office/drawing/2014/main" id="{474DE200-0181-4631-BBF0-B7A05984CD4F}"/>
+                <a16:creationId xmlns:a16="http://schemas.microsoft.com/office/drawing/2014/main" id="{42C1AD1E-D452-4041-A94B-7FDA7706944D}"/>
               </a:ext>
             </a:extLst>
           </p:cNvPr>
@@ -7603,7 +7591,7 @@
           <p:cNvPr id="10" name="">
             <a:extLst xmlns:a="http://schemas.openxmlformats.org/drawingml/2006/main">
               <a:ext uri="{FF2B5EF4-FFF2-40B4-BE49-F238E27FC236}">
-                <a16:creationId xmlns:a16="http://schemas.microsoft.com/office/drawing/2014/main" id="{78607BB5-F86E-4B52-9B6F-DBE058B4F114}"/>
+                <a16:creationId xmlns:a16="http://schemas.microsoft.com/office/drawing/2014/main" id="{2EAFE1EC-5FE8-47F1-9650-55AD764B2C44}"/>
               </a:ext>
             </a:extLst>
           </p:cNvPr>
@@ -7655,7 +7643,7 @@
           <p:cNvPr id="11" name="">
             <a:extLst xmlns:a="http://schemas.openxmlformats.org/drawingml/2006/main">
               <a:ext uri="{FF2B5EF4-FFF2-40B4-BE49-F238E27FC236}">
-                <a16:creationId xmlns:a16="http://schemas.microsoft.com/office/drawing/2014/main" id="{4C877DC3-C8A0-4B78-A438-ACBCBA633A4F}"/>
+                <a16:creationId xmlns:a16="http://schemas.microsoft.com/office/drawing/2014/main" id="{081761F3-91F1-4FDE-911E-2A4AE988E986}"/>
               </a:ext>
             </a:extLst>
           </p:cNvPr>
@@ -7707,7 +7695,7 @@
           <p:cNvPr id="12" name="">
             <a:extLst xmlns:a="http://schemas.openxmlformats.org/drawingml/2006/main">
               <a:ext uri="{FF2B5EF4-FFF2-40B4-BE49-F238E27FC236}">
-                <a16:creationId xmlns:a16="http://schemas.microsoft.com/office/drawing/2014/main" id="{8394BB22-E5EB-419F-A001-384F54810D41}"/>
+                <a16:creationId xmlns:a16="http://schemas.microsoft.com/office/drawing/2014/main" id="{57F88D0C-830A-4126-84AB-EEA0536C274C}"/>
               </a:ext>
             </a:extLst>
           </p:cNvPr>
@@ -7748,7 +7736,7 @@
           <p:cNvPr id="13" name="">
             <a:extLst xmlns:a="http://schemas.openxmlformats.org/drawingml/2006/main">
               <a:ext uri="{FF2B5EF4-FFF2-40B4-BE49-F238E27FC236}">
-                <a16:creationId xmlns:a16="http://schemas.microsoft.com/office/drawing/2014/main" id="{E9CAD373-754A-4E6B-B93D-9D23F1537F69}"/>
+                <a16:creationId xmlns:a16="http://schemas.microsoft.com/office/drawing/2014/main" id="{D9E502FF-6BDB-4438-9748-8ED402928021}"/>
               </a:ext>
             </a:extLst>
           </p:cNvPr>
@@ -7779,7 +7767,7 @@
           <p:cNvPr id="14" name="">
             <a:extLst xmlns:a="http://schemas.openxmlformats.org/drawingml/2006/main">
               <a:ext uri="{FF2B5EF4-FFF2-40B4-BE49-F238E27FC236}">
-                <a16:creationId xmlns:a16="http://schemas.microsoft.com/office/drawing/2014/main" id="{E92457C1-F15B-45EC-96FB-F53674292D42}"/>
+                <a16:creationId xmlns:a16="http://schemas.microsoft.com/office/drawing/2014/main" id="{24B08EC5-363F-41FC-97EB-7D5DECC1E36F}"/>
               </a:ext>
             </a:extLst>
           </p:cNvPr>
@@ -7831,7 +7819,7 @@
           <p:cNvPr id="15" name="">
             <a:extLst xmlns:a="http://schemas.openxmlformats.org/drawingml/2006/main">
               <a:ext uri="{FF2B5EF4-FFF2-40B4-BE49-F238E27FC236}">
-                <a16:creationId xmlns:a16="http://schemas.microsoft.com/office/drawing/2014/main" id="{0A4E4F05-AE70-4886-AEEA-AFE969C3F44F}"/>
+                <a16:creationId xmlns:a16="http://schemas.microsoft.com/office/drawing/2014/main" id="{7F36486E-4AA4-4CA4-8799-226643DDCE25}"/>
               </a:ext>
             </a:extLst>
           </p:cNvPr>
@@ -7883,7 +7871,7 @@
           <p:cNvPr id="16" name="">
             <a:extLst xmlns:a="http://schemas.openxmlformats.org/drawingml/2006/main">
               <a:ext uri="{FF2B5EF4-FFF2-40B4-BE49-F238E27FC236}">
-                <a16:creationId xmlns:a16="http://schemas.microsoft.com/office/drawing/2014/main" id="{62989EE1-CC1F-4F7E-BDE3-FA53492EF2FD}"/>
+                <a16:creationId xmlns:a16="http://schemas.microsoft.com/office/drawing/2014/main" id="{614EBDC2-5CF2-4081-A545-872CAFE698D2}"/>
               </a:ext>
             </a:extLst>
           </p:cNvPr>
@@ -7935,7 +7923,7 @@
           <p:cNvPr id="17" name="">
             <a:extLst xmlns:a="http://schemas.openxmlformats.org/drawingml/2006/main">
               <a:ext uri="{FF2B5EF4-FFF2-40B4-BE49-F238E27FC236}">
-                <a16:creationId xmlns:a16="http://schemas.microsoft.com/office/drawing/2014/main" id="{DD5FBE60-0896-4F07-B8A4-E260B6FCDDBA}"/>
+                <a16:creationId xmlns:a16="http://schemas.microsoft.com/office/drawing/2014/main" id="{B110C600-8811-4F3F-8BC1-8ECEF3545BBF}"/>
               </a:ext>
             </a:extLst>
           </p:cNvPr>
@@ -7985,7 +7973,7 @@
     </p:spTree>
     <p:extLst>
       <p:ext uri="{BB962C8B-B14F-4D97-AF65-F5344CB8AC3E}">
-        <p14:creationId xmlns:p14="http://schemas.microsoft.com/office/powerpoint/2010/main" val="345274168"/>
+        <p14:creationId xmlns:p14="http://schemas.microsoft.com/office/powerpoint/2010/main" val="341972578"/>
       </p:ext>
     </p:extLst>
   </p:cSld>
@@ -8016,7 +8004,7 @@
           <p:cNvPr id="14" name="">
             <a:extLst xmlns:a="http://schemas.openxmlformats.org/drawingml/2006/main">
               <a:ext uri="{FF2B5EF4-FFF2-40B4-BE49-F238E27FC236}">
-                <a16:creationId xmlns:a16="http://schemas.microsoft.com/office/drawing/2014/main" id="{1B20E8D5-0866-4C71-9419-1531A2CAE726}"/>
+                <a16:creationId xmlns:a16="http://schemas.microsoft.com/office/drawing/2014/main" id="{7FF3183B-4E67-45FB-A04A-90F04BC0F124}"/>
               </a:ext>
             </a:extLst>
           </p:cNvPr>
@@ -8068,7 +8056,7 @@
           <p:cNvPr id="2" name="">
             <a:extLst xmlns:a="http://schemas.openxmlformats.org/drawingml/2006/main">
               <a:ext uri="{FF2B5EF4-FFF2-40B4-BE49-F238E27FC236}">
-                <a16:creationId xmlns:a16="http://schemas.microsoft.com/office/drawing/2014/main" id="{C9622A15-A52B-4FC2-9832-1FD860FD2711}"/>
+                <a16:creationId xmlns:a16="http://schemas.microsoft.com/office/drawing/2014/main" id="{7F7EF155-BBC1-4D0E-AC11-8DDA3CF35277}"/>
               </a:ext>
             </a:extLst>
           </p:cNvPr>
@@ -8099,7 +8087,7 @@
           <p:cNvPr id="3" name="">
             <a:extLst xmlns:a="http://schemas.openxmlformats.org/drawingml/2006/main">
               <a:ext uri="{FF2B5EF4-FFF2-40B4-BE49-F238E27FC236}">
-                <a16:creationId xmlns:a16="http://schemas.microsoft.com/office/drawing/2014/main" id="{A4FAFF58-362A-4DE9-87FB-DB9B27CF08D4}"/>
+                <a16:creationId xmlns:a16="http://schemas.microsoft.com/office/drawing/2014/main" id="{8DFFE065-32CA-4B5C-9A34-E470CE3B6846}"/>
               </a:ext>
             </a:extLst>
           </p:cNvPr>
@@ -8151,7 +8139,7 @@
           <p:cNvPr id="4" name="">
             <a:extLst xmlns:a="http://schemas.openxmlformats.org/drawingml/2006/main">
               <a:ext uri="{FF2B5EF4-FFF2-40B4-BE49-F238E27FC236}">
-                <a16:creationId xmlns:a16="http://schemas.microsoft.com/office/drawing/2014/main" id="{EDFC0A57-AB72-4C1A-947D-3066F054E830}"/>
+                <a16:creationId xmlns:a16="http://schemas.microsoft.com/office/drawing/2014/main" id="{9B480758-FE21-4636-A413-D1CD0109D838}"/>
               </a:ext>
             </a:extLst>
           </p:cNvPr>
@@ -8192,7 +8180,7 @@
           <p:cNvPr id="5" name="">
             <a:extLst xmlns:a="http://schemas.openxmlformats.org/drawingml/2006/main">
               <a:ext uri="{FF2B5EF4-FFF2-40B4-BE49-F238E27FC236}">
-                <a16:creationId xmlns:a16="http://schemas.microsoft.com/office/drawing/2014/main" id="{ECCFC506-EC70-46B5-AF09-EDD034F04540}"/>
+                <a16:creationId xmlns:a16="http://schemas.microsoft.com/office/drawing/2014/main" id="{D0CD447B-1ABB-4980-B665-54901363DC2D}"/>
               </a:ext>
             </a:extLst>
           </p:cNvPr>
@@ -8223,7 +8211,7 @@
           <p:cNvPr id="6" name="">
             <a:extLst xmlns:a="http://schemas.openxmlformats.org/drawingml/2006/main">
               <a:ext uri="{FF2B5EF4-FFF2-40B4-BE49-F238E27FC236}">
-                <a16:creationId xmlns:a16="http://schemas.microsoft.com/office/drawing/2014/main" id="{EBA0F38B-2540-4E4A-95A2-588605A7AE87}"/>
+                <a16:creationId xmlns:a16="http://schemas.microsoft.com/office/drawing/2014/main" id="{15D601A7-CF12-4372-8F2D-A767433E76E8}"/>
               </a:ext>
             </a:extLst>
           </p:cNvPr>
@@ -8275,7 +8263,7 @@
           <p:cNvPr id="7" name="">
             <a:extLst xmlns:a="http://schemas.openxmlformats.org/drawingml/2006/main">
               <a:ext uri="{FF2B5EF4-FFF2-40B4-BE49-F238E27FC236}">
-                <a16:creationId xmlns:a16="http://schemas.microsoft.com/office/drawing/2014/main" id="{22E9B6A1-2B1C-4CC1-BD0A-DA571EC316BB}"/>
+                <a16:creationId xmlns:a16="http://schemas.microsoft.com/office/drawing/2014/main" id="{511D9CB7-97C4-4E52-ADF4-ADADDFD0BE24}"/>
               </a:ext>
             </a:extLst>
           </p:cNvPr>
@@ -8361,7 +8349,7 @@
           <p:cNvPr id="8" name="">
             <a:extLst xmlns:a="http://schemas.openxmlformats.org/drawingml/2006/main">
               <a:ext uri="{FF2B5EF4-FFF2-40B4-BE49-F238E27FC236}">
-                <a16:creationId xmlns:a16="http://schemas.microsoft.com/office/drawing/2014/main" id="{D78CB8CB-BE79-4204-8E65-1096256856EA}"/>
+                <a16:creationId xmlns:a16="http://schemas.microsoft.com/office/drawing/2014/main" id="{CDFF9106-3B28-4E5E-8070-BCE974743936}"/>
               </a:ext>
             </a:extLst>
           </p:cNvPr>
@@ -8402,7 +8390,7 @@
           <p:cNvPr id="9" name="">
             <a:extLst xmlns:a="http://schemas.openxmlformats.org/drawingml/2006/main">
               <a:ext uri="{FF2B5EF4-FFF2-40B4-BE49-F238E27FC236}">
-                <a16:creationId xmlns:a16="http://schemas.microsoft.com/office/drawing/2014/main" id="{936FA6C5-2405-4315-A7F7-73841332A8F5}"/>
+                <a16:creationId xmlns:a16="http://schemas.microsoft.com/office/drawing/2014/main" id="{F1347284-7F3B-4245-9F04-7AEDBDE410AD}"/>
               </a:ext>
             </a:extLst>
           </p:cNvPr>
@@ -8433,7 +8421,7 @@
           <p:cNvPr id="10" name="">
             <a:extLst xmlns:a="http://schemas.openxmlformats.org/drawingml/2006/main">
               <a:ext uri="{FF2B5EF4-FFF2-40B4-BE49-F238E27FC236}">
-                <a16:creationId xmlns:a16="http://schemas.microsoft.com/office/drawing/2014/main" id="{EB1D34F9-67F4-48FC-8D18-4183D87518A9}"/>
+                <a16:creationId xmlns:a16="http://schemas.microsoft.com/office/drawing/2014/main" id="{4662C0D0-6433-47E4-BE85-E124E82F6439}"/>
               </a:ext>
             </a:extLst>
           </p:cNvPr>
@@ -8485,7 +8473,7 @@
           <p:cNvPr id="11" name="">
             <a:extLst xmlns:a="http://schemas.openxmlformats.org/drawingml/2006/main">
               <a:ext uri="{FF2B5EF4-FFF2-40B4-BE49-F238E27FC236}">
-                <a16:creationId xmlns:a16="http://schemas.microsoft.com/office/drawing/2014/main" id="{355AC81B-C1C4-408D-B005-AA499BA55C64}"/>
+                <a16:creationId xmlns:a16="http://schemas.microsoft.com/office/drawing/2014/main" id="{2F0871AA-87C8-421C-BA02-C959304CE7D9}"/>
               </a:ext>
             </a:extLst>
           </p:cNvPr>
@@ -8571,7 +8559,7 @@
           <p:cNvPr id="12" name="">
             <a:extLst xmlns:a="http://schemas.openxmlformats.org/drawingml/2006/main">
               <a:ext uri="{FF2B5EF4-FFF2-40B4-BE49-F238E27FC236}">
-                <a16:creationId xmlns:a16="http://schemas.microsoft.com/office/drawing/2014/main" id="{E630F875-6635-4551-98B6-BB9836B76E53}"/>
+                <a16:creationId xmlns:a16="http://schemas.microsoft.com/office/drawing/2014/main" id="{89777701-8040-49C6-BDD2-96F6EE579D5E}"/>
               </a:ext>
             </a:extLst>
           </p:cNvPr>
@@ -8623,7 +8611,7 @@
           <p:cNvPr id="13" name="">
             <a:extLst xmlns:a="http://schemas.openxmlformats.org/drawingml/2006/main">
               <a:ext uri="{FF2B5EF4-FFF2-40B4-BE49-F238E27FC236}">
-                <a16:creationId xmlns:a16="http://schemas.microsoft.com/office/drawing/2014/main" id="{D3CD1A5E-6642-4209-8394-6191F6F239C0}"/>
+                <a16:creationId xmlns:a16="http://schemas.microsoft.com/office/drawing/2014/main" id="{F26612AB-3352-4B6B-983F-70B1FDC95A02}"/>
               </a:ext>
             </a:extLst>
           </p:cNvPr>
@@ -8673,7 +8661,7 @@
     </p:spTree>
     <p:extLst>
       <p:ext uri="{BB962C8B-B14F-4D97-AF65-F5344CB8AC3E}">
-        <p14:creationId xmlns:p14="http://schemas.microsoft.com/office/powerpoint/2010/main" val="142072184"/>
+        <p14:creationId xmlns:p14="http://schemas.microsoft.com/office/powerpoint/2010/main" val="1946247935"/>
       </p:ext>
     </p:extLst>
   </p:cSld>
@@ -8704,7 +8692,7 @@
           <p:cNvPr id="14" name="">
             <a:extLst xmlns:a="http://schemas.openxmlformats.org/drawingml/2006/main">
               <a:ext uri="{FF2B5EF4-FFF2-40B4-BE49-F238E27FC236}">
-                <a16:creationId xmlns:a16="http://schemas.microsoft.com/office/drawing/2014/main" id="{6701491C-00AB-4B30-8D76-6BDC2B2A6AC6}"/>
+                <a16:creationId xmlns:a16="http://schemas.microsoft.com/office/drawing/2014/main" id="{C5A2FA62-1645-454C-AD9C-08D4595F28E2}"/>
               </a:ext>
             </a:extLst>
           </p:cNvPr>
@@ -8756,7 +8744,7 @@
           <p:cNvPr id="2" name="">
             <a:extLst xmlns:a="http://schemas.openxmlformats.org/drawingml/2006/main">
               <a:ext uri="{FF2B5EF4-FFF2-40B4-BE49-F238E27FC236}">
-                <a16:creationId xmlns:a16="http://schemas.microsoft.com/office/drawing/2014/main" id="{C3BB1002-EB27-48C1-8810-18728F40E3C7}"/>
+                <a16:creationId xmlns:a16="http://schemas.microsoft.com/office/drawing/2014/main" id="{2694236D-A14D-4787-B698-068BB7CEC656}"/>
               </a:ext>
             </a:extLst>
           </p:cNvPr>
@@ -8787,7 +8775,7 @@
           <p:cNvPr id="3" name="">
             <a:extLst xmlns:a="http://schemas.openxmlformats.org/drawingml/2006/main">
               <a:ext uri="{FF2B5EF4-FFF2-40B4-BE49-F238E27FC236}">
-                <a16:creationId xmlns:a16="http://schemas.microsoft.com/office/drawing/2014/main" id="{25145EE2-5801-40EA-964D-EE9D7234ACC5}"/>
+                <a16:creationId xmlns:a16="http://schemas.microsoft.com/office/drawing/2014/main" id="{678BA9C7-52F2-439F-B7D8-7BE024C116BC}"/>
               </a:ext>
             </a:extLst>
           </p:cNvPr>
@@ -8839,7 +8827,7 @@
           <p:cNvPr id="4" name="">
             <a:extLst xmlns:a="http://schemas.openxmlformats.org/drawingml/2006/main">
               <a:ext uri="{FF2B5EF4-FFF2-40B4-BE49-F238E27FC236}">
-                <a16:creationId xmlns:a16="http://schemas.microsoft.com/office/drawing/2014/main" id="{7A3506E7-FD82-42FA-9E45-144F6A681BED}"/>
+                <a16:creationId xmlns:a16="http://schemas.microsoft.com/office/drawing/2014/main" id="{28111F71-A8AB-44CA-A488-F395AFC2C4F5}"/>
               </a:ext>
             </a:extLst>
           </p:cNvPr>
@@ -8880,7 +8868,7 @@
           <p:cNvPr id="5" name="">
             <a:extLst xmlns:a="http://schemas.openxmlformats.org/drawingml/2006/main">
               <a:ext uri="{FF2B5EF4-FFF2-40B4-BE49-F238E27FC236}">
-                <a16:creationId xmlns:a16="http://schemas.microsoft.com/office/drawing/2014/main" id="{FDC39745-4E7F-487E-8BE9-25C46952C6EE}"/>
+                <a16:creationId xmlns:a16="http://schemas.microsoft.com/office/drawing/2014/main" id="{A4982B61-CC4B-4FD5-8125-173EDC5BC03A}"/>
               </a:ext>
             </a:extLst>
           </p:cNvPr>
@@ -8911,7 +8899,7 @@
           <p:cNvPr id="6" name="">
             <a:extLst xmlns:a="http://schemas.openxmlformats.org/drawingml/2006/main">
               <a:ext uri="{FF2B5EF4-FFF2-40B4-BE49-F238E27FC236}">
-                <a16:creationId xmlns:a16="http://schemas.microsoft.com/office/drawing/2014/main" id="{50B439EF-7121-444D-A3B4-AF235DF1179E}"/>
+                <a16:creationId xmlns:a16="http://schemas.microsoft.com/office/drawing/2014/main" id="{6F84405C-F803-4E87-9B78-372119EBEAB3}"/>
               </a:ext>
             </a:extLst>
           </p:cNvPr>
@@ -8963,7 +8951,7 @@
           <p:cNvPr id="7" name="">
             <a:extLst xmlns:a="http://schemas.openxmlformats.org/drawingml/2006/main">
               <a:ext uri="{FF2B5EF4-FFF2-40B4-BE49-F238E27FC236}">
-                <a16:creationId xmlns:a16="http://schemas.microsoft.com/office/drawing/2014/main" id="{B2686BF2-3437-4793-B46B-DA3544C7527B}"/>
+                <a16:creationId xmlns:a16="http://schemas.microsoft.com/office/drawing/2014/main" id="{DEE5EC5F-04D7-4C52-A8D5-C205C93083C4}"/>
               </a:ext>
             </a:extLst>
           </p:cNvPr>
@@ -9049,7 +9037,7 @@
           <p:cNvPr id="8" name="">
             <a:extLst xmlns:a="http://schemas.openxmlformats.org/drawingml/2006/main">
               <a:ext uri="{FF2B5EF4-FFF2-40B4-BE49-F238E27FC236}">
-                <a16:creationId xmlns:a16="http://schemas.microsoft.com/office/drawing/2014/main" id="{D3483A67-45E4-4E59-9303-24098BB77DFE}"/>
+                <a16:creationId xmlns:a16="http://schemas.microsoft.com/office/drawing/2014/main" id="{E8D29654-7427-45ED-8089-CBCB79420F6B}"/>
               </a:ext>
             </a:extLst>
           </p:cNvPr>
@@ -9090,7 +9078,7 @@
           <p:cNvPr id="9" name="">
             <a:extLst xmlns:a="http://schemas.openxmlformats.org/drawingml/2006/main">
               <a:ext uri="{FF2B5EF4-FFF2-40B4-BE49-F238E27FC236}">
-                <a16:creationId xmlns:a16="http://schemas.microsoft.com/office/drawing/2014/main" id="{74B698F8-29D0-4939-8718-FF551D6441EF}"/>
+                <a16:creationId xmlns:a16="http://schemas.microsoft.com/office/drawing/2014/main" id="{5A4A08DD-3337-4DB2-8CD5-8BB46371308A}"/>
               </a:ext>
             </a:extLst>
           </p:cNvPr>
@@ -9121,7 +9109,7 @@
           <p:cNvPr id="10" name="">
             <a:extLst xmlns:a="http://schemas.openxmlformats.org/drawingml/2006/main">
               <a:ext uri="{FF2B5EF4-FFF2-40B4-BE49-F238E27FC236}">
-                <a16:creationId xmlns:a16="http://schemas.microsoft.com/office/drawing/2014/main" id="{10D9ED39-3EE2-4A57-9403-54368D2122A1}"/>
+                <a16:creationId xmlns:a16="http://schemas.microsoft.com/office/drawing/2014/main" id="{0A4DA21D-CC5F-411B-A2B2-49377495DDC4}"/>
               </a:ext>
             </a:extLst>
           </p:cNvPr>
@@ -9173,7 +9161,7 @@
           <p:cNvPr id="11" name="">
             <a:extLst xmlns:a="http://schemas.openxmlformats.org/drawingml/2006/main">
               <a:ext uri="{FF2B5EF4-FFF2-40B4-BE49-F238E27FC236}">
-                <a16:creationId xmlns:a16="http://schemas.microsoft.com/office/drawing/2014/main" id="{F5F66CAC-3369-4809-9FFF-95AD25126F9E}"/>
+                <a16:creationId xmlns:a16="http://schemas.microsoft.com/office/drawing/2014/main" id="{625B3B6C-035E-4DCE-8D59-FF2B488321B7}"/>
               </a:ext>
             </a:extLst>
           </p:cNvPr>
@@ -9276,7 +9264,7 @@
           <p:cNvPr id="12" name="">
             <a:extLst xmlns:a="http://schemas.openxmlformats.org/drawingml/2006/main">
               <a:ext uri="{FF2B5EF4-FFF2-40B4-BE49-F238E27FC236}">
-                <a16:creationId xmlns:a16="http://schemas.microsoft.com/office/drawing/2014/main" id="{E149E15E-AEE2-4471-AC26-7AB428EE2169}"/>
+                <a16:creationId xmlns:a16="http://schemas.microsoft.com/office/drawing/2014/main" id="{F5A78AFF-ECB4-45E4-85C4-63B7398131C2}"/>
               </a:ext>
             </a:extLst>
           </p:cNvPr>
@@ -9328,7 +9316,7 @@
           <p:cNvPr id="13" name="">
             <a:extLst xmlns:a="http://schemas.openxmlformats.org/drawingml/2006/main">
               <a:ext uri="{FF2B5EF4-FFF2-40B4-BE49-F238E27FC236}">
-                <a16:creationId xmlns:a16="http://schemas.microsoft.com/office/drawing/2014/main" id="{FE369D49-B84F-4580-BA59-169A51EA067A}"/>
+                <a16:creationId xmlns:a16="http://schemas.microsoft.com/office/drawing/2014/main" id="{667A88F6-2496-4F4E-B8CB-743958A7AD0E}"/>
               </a:ext>
             </a:extLst>
           </p:cNvPr>
@@ -9378,7 +9366,7 @@
     </p:spTree>
     <p:extLst>
       <p:ext uri="{BB962C8B-B14F-4D97-AF65-F5344CB8AC3E}">
-        <p14:creationId xmlns:p14="http://schemas.microsoft.com/office/powerpoint/2010/main" val="1198144438"/>
+        <p14:creationId xmlns:p14="http://schemas.microsoft.com/office/powerpoint/2010/main" val="341164776"/>
       </p:ext>
     </p:extLst>
   </p:cSld>
@@ -9413,7 +9401,7 @@
           <p:nvPr/>
         </p:nvPicPr>
         <p:blipFill>
-          <a:blip xmlns:r="http://schemas.openxmlformats.org/officeDocument/2006/relationships" xmlns:a="http://schemas.openxmlformats.org/drawingml/2006/main" r:embed="Rb9a40f27a9ce4c9e"/>
+          <a:blip xmlns:r="http://schemas.openxmlformats.org/officeDocument/2006/relationships" xmlns:a="http://schemas.openxmlformats.org/drawingml/2006/main" r:embed="Red3be73c3cab4ccc"/>
           <a:stretch xmlns:a="http://schemas.openxmlformats.org/drawingml/2006/main"/>
         </p:blipFill>
         <p:spPr>
@@ -9429,7 +9417,7 @@
     </p:spTree>
     <p:extLst>
       <p:ext uri="{BB962C8B-B14F-4D97-AF65-F5344CB8AC3E}">
-        <p14:creationId xmlns:p14="http://schemas.microsoft.com/office/powerpoint/2010/main" val="1643777629"/>
+        <p14:creationId xmlns:p14="http://schemas.microsoft.com/office/powerpoint/2010/main" val="513996541"/>
       </p:ext>
     </p:extLst>
   </p:cSld>
@@ -9464,7 +9452,7 @@
           <p:nvPr/>
         </p:nvPicPr>
         <p:blipFill>
-          <a:blip xmlns:r="http://schemas.openxmlformats.org/officeDocument/2006/relationships" xmlns:a="http://schemas.openxmlformats.org/drawingml/2006/main" r:embed="R05f88a08626343f6"/>
+          <a:blip xmlns:r="http://schemas.openxmlformats.org/officeDocument/2006/relationships" xmlns:a="http://schemas.openxmlformats.org/drawingml/2006/main" r:embed="Rcfff8fc48b0b4379"/>
           <a:stretch xmlns:a="http://schemas.openxmlformats.org/drawingml/2006/main"/>
         </p:blipFill>
         <p:spPr>
@@ -9480,7 +9468,7 @@
     </p:spTree>
     <p:extLst>
       <p:ext uri="{BB962C8B-B14F-4D97-AF65-F5344CB8AC3E}">
-        <p14:creationId xmlns:p14="http://schemas.microsoft.com/office/powerpoint/2010/main" val="211032403"/>
+        <p14:creationId xmlns:p14="http://schemas.microsoft.com/office/powerpoint/2010/main" val="703411525"/>
       </p:ext>
     </p:extLst>
   </p:cSld>
@@ -9511,7 +9499,7 @@
           <p:cNvPr id="13" name="">
             <a:extLst xmlns:a="http://schemas.openxmlformats.org/drawingml/2006/main">
               <a:ext uri="{FF2B5EF4-FFF2-40B4-BE49-F238E27FC236}">
-                <a16:creationId xmlns:a16="http://schemas.microsoft.com/office/drawing/2014/main" id="{79AC6AF2-B30A-478A-A398-CFEC04D8A37F}"/>
+                <a16:creationId xmlns:a16="http://schemas.microsoft.com/office/drawing/2014/main" id="{4444B16F-B50C-4BCF-AB8E-B92D2073115A}"/>
               </a:ext>
             </a:extLst>
           </p:cNvPr>
@@ -9563,7 +9551,7 @@
           <p:cNvPr id="2" name="">
             <a:extLst xmlns:a="http://schemas.openxmlformats.org/drawingml/2006/main">
               <a:ext uri="{FF2B5EF4-FFF2-40B4-BE49-F238E27FC236}">
-                <a16:creationId xmlns:a16="http://schemas.microsoft.com/office/drawing/2014/main" id="{C9A3C93B-4FBA-456D-A446-00378CE9D1DE}"/>
+                <a16:creationId xmlns:a16="http://schemas.microsoft.com/office/drawing/2014/main" id="{1741D2EC-9DAC-446B-A3CC-BFAE56050F01}"/>
               </a:ext>
             </a:extLst>
           </p:cNvPr>
@@ -9594,7 +9582,7 @@
           <p:cNvPr id="3" name="">
             <a:extLst xmlns:a="http://schemas.openxmlformats.org/drawingml/2006/main">
               <a:ext uri="{FF2B5EF4-FFF2-40B4-BE49-F238E27FC236}">
-                <a16:creationId xmlns:a16="http://schemas.microsoft.com/office/drawing/2014/main" id="{DE198ACD-9A77-48B1-9FB1-D7787F1DE228}"/>
+                <a16:creationId xmlns:a16="http://schemas.microsoft.com/office/drawing/2014/main" id="{76B4428B-F8D6-4F90-87DA-4B585C7AC630}"/>
               </a:ext>
             </a:extLst>
           </p:cNvPr>
@@ -9646,7 +9634,7 @@
           <p:cNvPr id="4" name="">
             <a:extLst xmlns:a="http://schemas.openxmlformats.org/drawingml/2006/main">
               <a:ext uri="{FF2B5EF4-FFF2-40B4-BE49-F238E27FC236}">
-                <a16:creationId xmlns:a16="http://schemas.microsoft.com/office/drawing/2014/main" id="{427EC643-33F2-4588-95F9-3DAE98247087}"/>
+                <a16:creationId xmlns:a16="http://schemas.microsoft.com/office/drawing/2014/main" id="{5F04E198-A274-40B4-85AC-C770DA60EE5E}"/>
               </a:ext>
             </a:extLst>
           </p:cNvPr>
@@ -9687,7 +9675,7 @@
           <p:cNvPr id="5" name="">
             <a:extLst xmlns:a="http://schemas.openxmlformats.org/drawingml/2006/main">
               <a:ext uri="{FF2B5EF4-FFF2-40B4-BE49-F238E27FC236}">
-                <a16:creationId xmlns:a16="http://schemas.microsoft.com/office/drawing/2014/main" id="{BB60F738-C64B-49AE-85F7-9E90D8903FD1}"/>
+                <a16:creationId xmlns:a16="http://schemas.microsoft.com/office/drawing/2014/main" id="{4CE30031-0942-4F28-88D4-72C3CBD5A4E5}"/>
               </a:ext>
             </a:extLst>
           </p:cNvPr>
@@ -9718,7 +9706,7 @@
           <p:cNvPr id="6" name="">
             <a:extLst xmlns:a="http://schemas.openxmlformats.org/drawingml/2006/main">
               <a:ext uri="{FF2B5EF4-FFF2-40B4-BE49-F238E27FC236}">
-                <a16:creationId xmlns:a16="http://schemas.microsoft.com/office/drawing/2014/main" id="{665FD62E-E1E2-482B-A637-0A2D2FC23CEE}"/>
+                <a16:creationId xmlns:a16="http://schemas.microsoft.com/office/drawing/2014/main" id="{720ECD6B-D167-4A67-AA31-FD6C491E00BD}"/>
               </a:ext>
             </a:extLst>
           </p:cNvPr>
@@ -9770,7 +9758,7 @@
           <p:cNvPr id="7" name="">
             <a:extLst xmlns:a="http://schemas.openxmlformats.org/drawingml/2006/main">
               <a:ext uri="{FF2B5EF4-FFF2-40B4-BE49-F238E27FC236}">
-                <a16:creationId xmlns:a16="http://schemas.microsoft.com/office/drawing/2014/main" id="{5B41A815-3748-49D9-823A-78A14E83DA44}"/>
+                <a16:creationId xmlns:a16="http://schemas.microsoft.com/office/drawing/2014/main" id="{54A15111-DE89-4879-949A-37F59D3E9C51}"/>
               </a:ext>
             </a:extLst>
           </p:cNvPr>
@@ -9856,7 +9844,7 @@
           <p:cNvPr id="8" name="">
             <a:extLst xmlns:a="http://schemas.openxmlformats.org/drawingml/2006/main">
               <a:ext uri="{FF2B5EF4-FFF2-40B4-BE49-F238E27FC236}">
-                <a16:creationId xmlns:a16="http://schemas.microsoft.com/office/drawing/2014/main" id="{CBB72817-3AC6-4D52-8459-20A40B88408B}"/>
+                <a16:creationId xmlns:a16="http://schemas.microsoft.com/office/drawing/2014/main" id="{762AA322-C7DB-4A53-BBD1-9998B4366D4A}"/>
               </a:ext>
             </a:extLst>
           </p:cNvPr>
@@ -9897,7 +9885,7 @@
           <p:cNvPr id="9" name="">
             <a:extLst xmlns:a="http://schemas.openxmlformats.org/drawingml/2006/main">
               <a:ext uri="{FF2B5EF4-FFF2-40B4-BE49-F238E27FC236}">
-                <a16:creationId xmlns:a16="http://schemas.microsoft.com/office/drawing/2014/main" id="{4D68FF6D-63F1-461D-B01C-B15809410379}"/>
+                <a16:creationId xmlns:a16="http://schemas.microsoft.com/office/drawing/2014/main" id="{E516EF76-E016-4A0D-B7EE-3FB4E39144A6}"/>
               </a:ext>
             </a:extLst>
           </p:cNvPr>
@@ -9928,7 +9916,7 @@
           <p:cNvPr id="10" name="">
             <a:extLst xmlns:a="http://schemas.openxmlformats.org/drawingml/2006/main">
               <a:ext uri="{FF2B5EF4-FFF2-40B4-BE49-F238E27FC236}">
-                <a16:creationId xmlns:a16="http://schemas.microsoft.com/office/drawing/2014/main" id="{D99881F4-2CFA-414A-B39D-016BC46E1423}"/>
+                <a16:creationId xmlns:a16="http://schemas.microsoft.com/office/drawing/2014/main" id="{638FBA3F-4227-414F-BE2D-E791F605E631}"/>
               </a:ext>
             </a:extLst>
           </p:cNvPr>
@@ -9980,7 +9968,7 @@
           <p:cNvPr id="11" name="">
             <a:extLst xmlns:a="http://schemas.openxmlformats.org/drawingml/2006/main">
               <a:ext uri="{FF2B5EF4-FFF2-40B4-BE49-F238E27FC236}">
-                <a16:creationId xmlns:a16="http://schemas.microsoft.com/office/drawing/2014/main" id="{B3404F02-08E8-4067-928A-D3AB95055E9E}"/>
+                <a16:creationId xmlns:a16="http://schemas.microsoft.com/office/drawing/2014/main" id="{BB2C3F83-2837-4D5C-A5BA-77ED51A1EDAB}"/>
               </a:ext>
             </a:extLst>
           </p:cNvPr>
@@ -10083,7 +10071,7 @@
           <p:cNvPr id="12" name="">
             <a:extLst xmlns:a="http://schemas.openxmlformats.org/drawingml/2006/main">
               <a:ext uri="{FF2B5EF4-FFF2-40B4-BE49-F238E27FC236}">
-                <a16:creationId xmlns:a16="http://schemas.microsoft.com/office/drawing/2014/main" id="{A57A546A-8F52-40E5-ACCB-289BC116984D}"/>
+                <a16:creationId xmlns:a16="http://schemas.microsoft.com/office/drawing/2014/main" id="{137DBF89-40A6-4AFA-B9F6-C966B54E6F6F}"/>
               </a:ext>
             </a:extLst>
           </p:cNvPr>
@@ -10133,7 +10121,7 @@
     </p:spTree>
     <p:extLst>
       <p:ext uri="{BB962C8B-B14F-4D97-AF65-F5344CB8AC3E}">
-        <p14:creationId xmlns:p14="http://schemas.microsoft.com/office/powerpoint/2010/main" val="1761925384"/>
+        <p14:creationId xmlns:p14="http://schemas.microsoft.com/office/powerpoint/2010/main" val="723990584"/>
       </p:ext>
     </p:extLst>
   </p:cSld>
@@ -10164,7 +10152,7 @@
           <p:cNvPr id="17" name="">
             <a:extLst xmlns:a="http://schemas.openxmlformats.org/drawingml/2006/main">
               <a:ext uri="{FF2B5EF4-FFF2-40B4-BE49-F238E27FC236}">
-                <a16:creationId xmlns:a16="http://schemas.microsoft.com/office/drawing/2014/main" id="{F6B06499-7FA2-4C70-93EB-2EF1A3AFAD64}"/>
+                <a16:creationId xmlns:a16="http://schemas.microsoft.com/office/drawing/2014/main" id="{270F6CE9-75E2-428C-B938-CEB6C0F123F3}"/>
               </a:ext>
             </a:extLst>
           </p:cNvPr>
@@ -10216,7 +10204,7 @@
           <p:cNvPr id="2" name="">
             <a:extLst xmlns:a="http://schemas.openxmlformats.org/drawingml/2006/main">
               <a:ext uri="{FF2B5EF4-FFF2-40B4-BE49-F238E27FC236}">
-                <a16:creationId xmlns:a16="http://schemas.microsoft.com/office/drawing/2014/main" id="{AE465453-7922-49EA-8215-E0CE3D508F78}"/>
+                <a16:creationId xmlns:a16="http://schemas.microsoft.com/office/drawing/2014/main" id="{8A18E0D5-7B1B-4FD4-931B-4ABD75D64E91}"/>
               </a:ext>
             </a:extLst>
           </p:cNvPr>
@@ -10247,7 +10235,7 @@
           <p:cNvPr id="3" name="">
             <a:extLst xmlns:a="http://schemas.openxmlformats.org/drawingml/2006/main">
               <a:ext uri="{FF2B5EF4-FFF2-40B4-BE49-F238E27FC236}">
-                <a16:creationId xmlns:a16="http://schemas.microsoft.com/office/drawing/2014/main" id="{CA28DFA3-734E-4D75-8B60-8EDD9DC00335}"/>
+                <a16:creationId xmlns:a16="http://schemas.microsoft.com/office/drawing/2014/main" id="{D9C796CF-ABD8-4830-88EC-3B0E372C048F}"/>
               </a:ext>
             </a:extLst>
           </p:cNvPr>
@@ -10299,7 +10287,7 @@
           <p:cNvPr id="4" name="">
             <a:extLst xmlns:a="http://schemas.openxmlformats.org/drawingml/2006/main">
               <a:ext uri="{FF2B5EF4-FFF2-40B4-BE49-F238E27FC236}">
-                <a16:creationId xmlns:a16="http://schemas.microsoft.com/office/drawing/2014/main" id="{08B87CEE-0DB4-4647-980C-A74C09AB1AC8}"/>
+                <a16:creationId xmlns:a16="http://schemas.microsoft.com/office/drawing/2014/main" id="{E2F0A727-2949-4F45-B82E-4E76E4B49DA4}"/>
               </a:ext>
             </a:extLst>
           </p:cNvPr>
@@ -10340,7 +10328,7 @@
           <p:cNvPr id="5" name="">
             <a:extLst xmlns:a="http://schemas.openxmlformats.org/drawingml/2006/main">
               <a:ext uri="{FF2B5EF4-FFF2-40B4-BE49-F238E27FC236}">
-                <a16:creationId xmlns:a16="http://schemas.microsoft.com/office/drawing/2014/main" id="{00235E04-6C69-4863-A6A6-5B707EAD080E}"/>
+                <a16:creationId xmlns:a16="http://schemas.microsoft.com/office/drawing/2014/main" id="{C4B5DF43-C9C1-4BD9-B8FE-3F21A0CEBDED}"/>
               </a:ext>
             </a:extLst>
           </p:cNvPr>
@@ -10371,7 +10359,7 @@
           <p:cNvPr id="6" name="">
             <a:extLst xmlns:a="http://schemas.openxmlformats.org/drawingml/2006/main">
               <a:ext uri="{FF2B5EF4-FFF2-40B4-BE49-F238E27FC236}">
-                <a16:creationId xmlns:a16="http://schemas.microsoft.com/office/drawing/2014/main" id="{F3BA78FD-D573-4D01-B6CC-06012F04236B}"/>
+                <a16:creationId xmlns:a16="http://schemas.microsoft.com/office/drawing/2014/main" id="{DE85D7A8-3D0D-48D2-A8D2-050F63E5F77E}"/>
               </a:ext>
             </a:extLst>
           </p:cNvPr>
@@ -10423,7 +10411,7 @@
           <p:cNvPr id="7" name="">
             <a:extLst xmlns:a="http://schemas.openxmlformats.org/drawingml/2006/main">
               <a:ext uri="{FF2B5EF4-FFF2-40B4-BE49-F238E27FC236}">
-                <a16:creationId xmlns:a16="http://schemas.microsoft.com/office/drawing/2014/main" id="{E2DCE172-2086-46C1-999D-8B11B6A7F35B}"/>
+                <a16:creationId xmlns:a16="http://schemas.microsoft.com/office/drawing/2014/main" id="{01D67532-285F-4551-A92D-E9C7E25BF615}"/>
               </a:ext>
             </a:extLst>
           </p:cNvPr>
@@ -10475,7 +10463,7 @@
           <p:cNvPr id="8" name="">
             <a:extLst xmlns:a="http://schemas.openxmlformats.org/drawingml/2006/main">
               <a:ext uri="{FF2B5EF4-FFF2-40B4-BE49-F238E27FC236}">
-                <a16:creationId xmlns:a16="http://schemas.microsoft.com/office/drawing/2014/main" id="{62CE0F21-7BF4-42DB-856A-F21560F510AE}"/>
+                <a16:creationId xmlns:a16="http://schemas.microsoft.com/office/drawing/2014/main" id="{854D685A-D472-49E9-8C1B-225841981EF9}"/>
               </a:ext>
             </a:extLst>
           </p:cNvPr>
@@ -10516,7 +10504,7 @@
           <p:cNvPr id="9" name="">
             <a:extLst xmlns:a="http://schemas.openxmlformats.org/drawingml/2006/main">
               <a:ext uri="{FF2B5EF4-FFF2-40B4-BE49-F238E27FC236}">
-                <a16:creationId xmlns:a16="http://schemas.microsoft.com/office/drawing/2014/main" id="{4A8ABB1B-BDB3-4CD8-A212-7864FA874471}"/>
+                <a16:creationId xmlns:a16="http://schemas.microsoft.com/office/drawing/2014/main" id="{FC5A5A8B-55C8-4ED6-879F-6CA802F2EE1C}"/>
               </a:ext>
             </a:extLst>
           </p:cNvPr>
@@ -10547,7 +10535,7 @@
           <p:cNvPr id="10" name="">
             <a:extLst xmlns:a="http://schemas.openxmlformats.org/drawingml/2006/main">
               <a:ext uri="{FF2B5EF4-FFF2-40B4-BE49-F238E27FC236}">
-                <a16:creationId xmlns:a16="http://schemas.microsoft.com/office/drawing/2014/main" id="{7A4BD399-923F-4618-9278-9AA83D6EC169}"/>
+                <a16:creationId xmlns:a16="http://schemas.microsoft.com/office/drawing/2014/main" id="{192768FF-5166-459B-9D3A-A670A4FAF7B9}"/>
               </a:ext>
             </a:extLst>
           </p:cNvPr>
@@ -10599,7 +10587,7 @@
           <p:cNvPr id="11" name="">
             <a:extLst xmlns:a="http://schemas.openxmlformats.org/drawingml/2006/main">
               <a:ext uri="{FF2B5EF4-FFF2-40B4-BE49-F238E27FC236}">
-                <a16:creationId xmlns:a16="http://schemas.microsoft.com/office/drawing/2014/main" id="{77D81919-EDE3-4E7B-8CA7-A11918B68861}"/>
+                <a16:creationId xmlns:a16="http://schemas.microsoft.com/office/drawing/2014/main" id="{21D21ECE-6EC7-42AE-B09C-CC73E81852CB}"/>
               </a:ext>
             </a:extLst>
           </p:cNvPr>
@@ -10651,7 +10639,7 @@
           <p:cNvPr id="12" name="">
             <a:extLst xmlns:a="http://schemas.openxmlformats.org/drawingml/2006/main">
               <a:ext uri="{FF2B5EF4-FFF2-40B4-BE49-F238E27FC236}">
-                <a16:creationId xmlns:a16="http://schemas.microsoft.com/office/drawing/2014/main" id="{2F06F18F-375E-4913-810F-512150D79D31}"/>
+                <a16:creationId xmlns:a16="http://schemas.microsoft.com/office/drawing/2014/main" id="{19CD6C5D-2C66-4BBD-B3D3-21066F57B7B7}"/>
               </a:ext>
             </a:extLst>
           </p:cNvPr>
@@ -10692,7 +10680,7 @@
           <p:cNvPr id="13" name="">
             <a:extLst xmlns:a="http://schemas.openxmlformats.org/drawingml/2006/main">
               <a:ext uri="{FF2B5EF4-FFF2-40B4-BE49-F238E27FC236}">
-                <a16:creationId xmlns:a16="http://schemas.microsoft.com/office/drawing/2014/main" id="{A6535C18-9B6A-4E0C-ABCE-A7964A8206BA}"/>
+                <a16:creationId xmlns:a16="http://schemas.microsoft.com/office/drawing/2014/main" id="{6819DAFF-A76A-4A8B-844B-2F6203CBE8F6}"/>
               </a:ext>
             </a:extLst>
           </p:cNvPr>
@@ -10723,7 +10711,7 @@
           <p:cNvPr id="14" name="">
             <a:extLst xmlns:a="http://schemas.openxmlformats.org/drawingml/2006/main">
               <a:ext uri="{FF2B5EF4-FFF2-40B4-BE49-F238E27FC236}">
-                <a16:creationId xmlns:a16="http://schemas.microsoft.com/office/drawing/2014/main" id="{0687B8D7-0007-440B-89B5-F299C7A89849}"/>
+                <a16:creationId xmlns:a16="http://schemas.microsoft.com/office/drawing/2014/main" id="{0BAD717D-5A04-4A9E-9F84-0A2DE93CCFBC}"/>
               </a:ext>
             </a:extLst>
           </p:cNvPr>
@@ -10775,7 +10763,7 @@
           <p:cNvPr id="15" name="">
             <a:extLst xmlns:a="http://schemas.openxmlformats.org/drawingml/2006/main">
               <a:ext uri="{FF2B5EF4-FFF2-40B4-BE49-F238E27FC236}">
-                <a16:creationId xmlns:a16="http://schemas.microsoft.com/office/drawing/2014/main" id="{26D7524F-27CE-4F37-A2F9-0752C22E12A2}"/>
+                <a16:creationId xmlns:a16="http://schemas.microsoft.com/office/drawing/2014/main" id="{4FBC47AC-73FD-4DA7-AE22-440772A9AACC}"/>
               </a:ext>
             </a:extLst>
           </p:cNvPr>
@@ -10827,7 +10815,7 @@
           <p:cNvPr id="16" name="">
             <a:extLst xmlns:a="http://schemas.openxmlformats.org/drawingml/2006/main">
               <a:ext uri="{FF2B5EF4-FFF2-40B4-BE49-F238E27FC236}">
-                <a16:creationId xmlns:a16="http://schemas.microsoft.com/office/drawing/2014/main" id="{89AA804E-A17D-47A0-BC73-CD3511AF20B5}"/>
+                <a16:creationId xmlns:a16="http://schemas.microsoft.com/office/drawing/2014/main" id="{6E16A8EF-D1DE-4730-8DEF-5B416384E70E}"/>
               </a:ext>
             </a:extLst>
           </p:cNvPr>
@@ -10877,7 +10865,7 @@
     </p:spTree>
     <p:extLst>
       <p:ext uri="{BB962C8B-B14F-4D97-AF65-F5344CB8AC3E}">
-        <p14:creationId xmlns:p14="http://schemas.microsoft.com/office/powerpoint/2010/main" val="1126157644"/>
+        <p14:creationId xmlns:p14="http://schemas.microsoft.com/office/powerpoint/2010/main" val="740166493"/>
       </p:ext>
     </p:extLst>
   </p:cSld>

</xml_diff>